<commit_message>
update slides for Mimi
</commit_message>
<xml_diff>
--- a/presentations/0609_FINAL_merged_Stablecoin_Privilege.pptx
+++ b/presentations/0609_FINAL_merged_Stablecoin_Privilege.pptx
@@ -5,30 +5,30 @@
     <p:sldMasterId id="2147483648" r:id="rId1"/>
   </p:sldMasterIdLst>
   <p:notesMasterIdLst>
-    <p:notesMasterId r:id="rId4"/>
+    <p:notesMasterId r:id="rId23"/>
   </p:notesMasterIdLst>
   <p:sldIdLst>
-    <p:sldId id="256" r:id="rId3"/>
-    <p:sldId id="257" r:id="rId5"/>
-    <p:sldId id="258" r:id="rId6"/>
-    <p:sldId id="276" r:id="rId7"/>
-    <p:sldId id="260" r:id="rId8"/>
-    <p:sldId id="261" r:id="rId9"/>
-    <p:sldId id="262" r:id="rId10"/>
-    <p:sldId id="263" r:id="rId11"/>
-    <p:sldId id="280" r:id="rId12"/>
-    <p:sldId id="264" r:id="rId13"/>
-    <p:sldId id="277" r:id="rId14"/>
-    <p:sldId id="266" r:id="rId15"/>
-    <p:sldId id="268" r:id="rId16"/>
-    <p:sldId id="269" r:id="rId17"/>
-    <p:sldId id="281" r:id="rId18"/>
-    <p:sldId id="270" r:id="rId19"/>
-    <p:sldId id="271" r:id="rId20"/>
-    <p:sldId id="272" r:id="rId21"/>
-    <p:sldId id="273" r:id="rId22"/>
-    <p:sldId id="274" r:id="rId23"/>
-    <p:sldId id="275" r:id="rId24"/>
+    <p:sldId id="256" r:id="rId2"/>
+    <p:sldId id="257" r:id="rId3"/>
+    <p:sldId id="258" r:id="rId4"/>
+    <p:sldId id="276" r:id="rId5"/>
+    <p:sldId id="260" r:id="rId6"/>
+    <p:sldId id="261" r:id="rId7"/>
+    <p:sldId id="262" r:id="rId8"/>
+    <p:sldId id="263" r:id="rId9"/>
+    <p:sldId id="280" r:id="rId10"/>
+    <p:sldId id="264" r:id="rId11"/>
+    <p:sldId id="277" r:id="rId12"/>
+    <p:sldId id="266" r:id="rId13"/>
+    <p:sldId id="268" r:id="rId14"/>
+    <p:sldId id="269" r:id="rId15"/>
+    <p:sldId id="281" r:id="rId16"/>
+    <p:sldId id="270" r:id="rId17"/>
+    <p:sldId id="271" r:id="rId18"/>
+    <p:sldId id="272" r:id="rId19"/>
+    <p:sldId id="273" r:id="rId20"/>
+    <p:sldId id="274" r:id="rId21"/>
+    <p:sldId id="275" r:id="rId22"/>
   </p:sldIdLst>
   <p:sldSz cx="12192000" cy="6858000"/>
   <p:notesSz cx="6858000" cy="12192000"/>
@@ -124,13 +124,18 @@
       </a:defRPr>
     </a:lvl9pPr>
   </p:defaultTextStyle>
+  <p:extLst>
+    <p:ext uri="{EFAFB233-063F-42B5-8137-9DF3F51BA10A}">
+      <p15:sldGuideLst xmlns:p15="http://schemas.microsoft.com/office/powerpoint/2012/main"/>
+    </p:ext>
+  </p:extLst>
 </p:presentation>
 </file>
 
 <file path=ppt/charts/chart1.xml><?xml version="1.0" encoding="utf-8"?>
-<c:chartSpace xmlns:c="http://schemas.openxmlformats.org/drawingml/2006/chart" xmlns:a="http://schemas.openxmlformats.org/drawingml/2006/main" xmlns:r="http://schemas.openxmlformats.org/officeDocument/2006/relationships">
+<c:chartSpace xmlns:c="http://schemas.openxmlformats.org/drawingml/2006/chart" xmlns:a="http://schemas.openxmlformats.org/drawingml/2006/main" xmlns:r="http://schemas.openxmlformats.org/officeDocument/2006/relationships" xmlns:c16r2="http://schemas.microsoft.com/office/drawing/2015/06/chart">
   <c:date1904 val="0"/>
-  <c:lang val="zh-CN"/>
+  <c:lang val="ko-KR"/>
   <c:roundedCorners val="1"/>
   <mc:AlternateContent xmlns:mc="http://schemas.openxmlformats.org/markup-compatibility/2006">
     <mc:Choice xmlns:c14="http://schemas.microsoft.com/office/drawing/2007/8/2/chart" Requires="c14">
@@ -192,6 +197,7 @@
                     <a:cs typeface="+mn-cs"/>
                   </a:defRPr>
                 </a:pPr>
+                <a:endParaRPr lang="ko-KR"/>
               </a:p>
             </c:txPr>
             <c:dLblPos val="outEnd"/>
@@ -204,9 +210,7 @@
             <c:showLeaderLines val="0"/>
             <c:extLst>
               <c:ext xmlns:c15="http://schemas.microsoft.com/office/drawing/2012/chart" uri="{CE6537A1-D6FC-4f65-9D91-7224C49458BB}">
-                <c15:layout/>
                 <c15:showLeaderLines val="0"/>
-                <c15:leaderLines/>
               </c:ext>
             </c:extLst>
           </c:dLbls>
@@ -237,7 +241,7 @@
                   <c:v>84.8</c:v>
                 </c:pt>
                 <c:pt idx="1">
-                  <c:v>70.9</c:v>
+                  <c:v>70.900000000000006</c:v>
                 </c:pt>
                 <c:pt idx="2">
                   <c:v>0.2</c:v>
@@ -245,6 +249,11 @@
               </c:numCache>
             </c:numRef>
           </c:val>
+          <c:extLst>
+            <c:ext xmlns:c16="http://schemas.microsoft.com/office/drawing/2014/chart" uri="{C3380CC4-5D6E-409C-BE32-E72D297353CC}">
+              <c16:uniqueId val="{00000000-8BA2-0649-9647-185E7E1B1DAE}"/>
+            </c:ext>
+          </c:extLst>
         </c:ser>
         <c:ser>
           <c:idx val="1"/>
@@ -290,6 +299,7 @@
                     <a:cs typeface="+mn-cs"/>
                   </a:defRPr>
                 </a:pPr>
+                <a:endParaRPr lang="ko-KR"/>
               </a:p>
             </c:txPr>
             <c:dLblPos val="outEnd"/>
@@ -302,9 +312,7 @@
             <c:showLeaderLines val="0"/>
             <c:extLst>
               <c:ext xmlns:c15="http://schemas.microsoft.com/office/drawing/2012/chart" uri="{CE6537A1-D6FC-4f65-9D91-7224C49458BB}">
-                <c15:layout/>
                 <c15:showLeaderLines val="0"/>
-                <c15:leaderLines/>
               </c:ext>
             </c:extLst>
           </c:dLbls>
@@ -332,7 +340,7 @@
                 <c:formatCode>General</c:formatCode>
                 <c:ptCount val="3"/>
                 <c:pt idx="0">
-                  <c:v>16.6</c:v>
+                  <c:v>16.600000000000001</c:v>
                 </c:pt>
                 <c:pt idx="1">
                   <c:v>14</c:v>
@@ -343,6 +351,11 @@
               </c:numCache>
             </c:numRef>
           </c:val>
+          <c:extLst>
+            <c:ext xmlns:c16="http://schemas.microsoft.com/office/drawing/2014/chart" uri="{C3380CC4-5D6E-409C-BE32-E72D297353CC}">
+              <c16:uniqueId val="{00000001-8BA2-0649-9647-185E7E1B1DAE}"/>
+            </c:ext>
+          </c:extLst>
         </c:ser>
         <c:dLbls>
           <c:showLegendKey val="0"/>
@@ -353,7 +366,6 @@
           <c:showBubbleSize val="0"/>
         </c:dLbls>
         <c:gapWidth val="150"/>
-        <c:overlap val="0"/>
         <c:axId val="2094734554"/>
         <c:axId val="2094734552"/>
       </c:barChart>
@@ -391,6 +403,7 @@
                 <a:cs typeface="+mn-cs"/>
               </a:defRPr>
             </a:pPr>
+            <a:endParaRPr lang="ko-KR"/>
           </a:p>
         </c:txPr>
         <c:crossAx val="2094734552"/>
@@ -411,22 +424,6 @@
         <c:majorTickMark val="out"/>
         <c:minorTickMark val="none"/>
         <c:tickLblPos val="nextTo"/>
-        <c:txPr>
-          <a:bodyPr rot="-60000000" spcFirstLastPara="0" vertOverflow="ellipsis" vert="horz" wrap="square" anchor="ctr" anchorCtr="1"/>
-          <a:lstStyle/>
-          <a:p>
-            <a:pPr>
-              <a:defRPr lang="en-US" sz="1200" b="0" i="0" u="none" strike="noStrike" kern="1200" baseline="0">
-                <a:solidFill>
-                  <a:srgbClr val="000000"/>
-                </a:solidFill>
-                <a:latin typeface="Arial" panose="020B0704020202020204"/>
-                <a:ea typeface="+mn-ea"/>
-                <a:cs typeface="+mn-cs"/>
-              </a:defRPr>
-            </a:pPr>
-          </a:p>
-        </c:txPr>
         <c:crossAx val="2094734554"/>
         <c:crosses val="autoZero"/>
         <c:crossBetween val="between"/>
@@ -441,7 +438,6 @@
     </c:plotArea>
     <c:legend>
       <c:legendPos val="b"/>
-      <c:layout/>
       <c:overlay val="0"/>
       <c:txPr>
         <a:bodyPr rot="0" spcFirstLastPara="0" vertOverflow="ellipsis" vert="horz" wrap="square" anchor="ctr" anchorCtr="1"/>
@@ -457,6 +453,7 @@
               <a:cs typeface="+mn-cs"/>
             </a:defRPr>
           </a:pPr>
+          <a:endParaRPr lang="ko-KR"/>
         </a:p>
       </c:txPr>
     </c:legend>
@@ -483,6 +480,7 @@
       <a:pPr>
         <a:defRPr lang="en-US"/>
       </a:pPr>
+      <a:endParaRPr lang="ko-KR"/>
     </a:p>
   </c:txPr>
   <c:externalData r:id="rId1">
@@ -573,6 +571,7 @@
           <a:p>
             <a:fld id="{5282F153-3F37-0F45-9E97-73ACFA13230C}" type="datetimeFigureOut">
               <a:rPr lang="en-US"/>
+              <a:t>6/9/26</a:t>
             </a:fld>
             <a:endParaRPr lang="en-US"/>
           </a:p>
@@ -639,7 +638,6 @@
               <a:rPr lang="en-US"/>
               <a:t>Click to edit Master text styles</a:t>
             </a:r>
-            <a:endParaRPr lang="en-US"/>
           </a:p>
           <a:p>
             <a:pPr lvl="1"/>
@@ -647,7 +645,6 @@
               <a:rPr lang="en-US"/>
               <a:t>Second level</a:t>
             </a:r>
-            <a:endParaRPr lang="en-US"/>
           </a:p>
           <a:p>
             <a:pPr lvl="2"/>
@@ -655,7 +652,6 @@
               <a:rPr lang="en-US"/>
               <a:t>Third level</a:t>
             </a:r>
-            <a:endParaRPr lang="en-US"/>
           </a:p>
           <a:p>
             <a:pPr lvl="3"/>
@@ -663,7 +659,6 @@
               <a:rPr lang="en-US"/>
               <a:t>Fourth level</a:t>
             </a:r>
-            <a:endParaRPr lang="en-US"/>
           </a:p>
           <a:p>
             <a:pPr lvl="4"/>
@@ -671,7 +666,6 @@
               <a:rPr lang="en-US"/>
               <a:t>Fifth level</a:t>
             </a:r>
-            <a:endParaRPr lang="en-US"/>
           </a:p>
         </p:txBody>
       </p:sp>
@@ -735,6 +729,7 @@
           <a:p>
             <a:fld id="{CE5E9CC1-C706-0F49-92D6-E571CC5EEA8F}" type="slidenum">
               <a:rPr lang="en-US"/>
+              <a:t>‹#›</a:t>
             </a:fld>
             <a:endParaRPr lang="en-US"/>
           </a:p>
@@ -903,6 +898,7 @@
           <a:p>
             <a:fld id="{F7021451-1387-4CA6-816F-3879F97B5CBC}" type="slidenum">
               <a:rPr lang="en-US"/>
+              <a:t>1</a:t>
             </a:fld>
             <a:endParaRPr lang="en-US"/>
           </a:p>
@@ -981,6 +977,7 @@
           <a:p>
             <a:fld id="{F7021451-1387-4CA6-816F-3879F97B5CBC}" type="slidenum">
               <a:rPr lang="en-US"/>
+              <a:t>10</a:t>
             </a:fld>
             <a:endParaRPr lang="en-US"/>
           </a:p>
@@ -1059,6 +1056,7 @@
           <a:p>
             <a:fld id="{F7021451-1387-4CA6-816F-3879F97B5CBC}" type="slidenum">
               <a:rPr lang="en-US"/>
+              <a:t>11</a:t>
             </a:fld>
             <a:endParaRPr lang="en-US"/>
           </a:p>
@@ -1137,6 +1135,7 @@
           <a:p>
             <a:fld id="{F7021451-1387-4CA6-816F-3879F97B5CBC}" type="slidenum">
               <a:rPr lang="en-US"/>
+              <a:t>12</a:t>
             </a:fld>
             <a:endParaRPr lang="en-US"/>
           </a:p>
@@ -1215,6 +1214,7 @@
           <a:p>
             <a:fld id="{F7021451-1387-4CA6-816F-3879F97B5CBC}" type="slidenum">
               <a:rPr lang="en-US"/>
+              <a:t>13</a:t>
             </a:fld>
             <a:endParaRPr lang="en-US"/>
           </a:p>
@@ -1293,6 +1293,7 @@
           <a:p>
             <a:fld id="{F7021451-1387-4CA6-816F-3879F97B5CBC}" type="slidenum">
               <a:rPr lang="en-US"/>
+              <a:t>14</a:t>
             </a:fld>
             <a:endParaRPr lang="en-US"/>
           </a:p>
@@ -1371,6 +1372,7 @@
           <a:p>
             <a:fld id="{F7021451-1387-4CA6-816F-3879F97B5CBC}" type="slidenum">
               <a:rPr lang="en-US"/>
+              <a:t>15</a:t>
             </a:fld>
             <a:endParaRPr lang="en-US"/>
           </a:p>
@@ -1449,6 +1451,7 @@
           <a:p>
             <a:fld id="{F7021451-1387-4CA6-816F-3879F97B5CBC}" type="slidenum">
               <a:rPr lang="en-US"/>
+              <a:t>16</a:t>
             </a:fld>
             <a:endParaRPr lang="en-US"/>
           </a:p>
@@ -1527,6 +1530,7 @@
           <a:p>
             <a:fld id="{F7021451-1387-4CA6-816F-3879F97B5CBC}" type="slidenum">
               <a:rPr lang="en-US"/>
+              <a:t>17</a:t>
             </a:fld>
             <a:endParaRPr lang="en-US"/>
           </a:p>
@@ -1605,6 +1609,7 @@
           <a:p>
             <a:fld id="{F7021451-1387-4CA6-816F-3879F97B5CBC}" type="slidenum">
               <a:rPr lang="en-US"/>
+              <a:t>18</a:t>
             </a:fld>
             <a:endParaRPr lang="en-US"/>
           </a:p>
@@ -1683,6 +1688,7 @@
           <a:p>
             <a:fld id="{F7021451-1387-4CA6-816F-3879F97B5CBC}" type="slidenum">
               <a:rPr lang="en-US"/>
+              <a:t>19</a:t>
             </a:fld>
             <a:endParaRPr lang="en-US"/>
           </a:p>
@@ -1761,6 +1767,7 @@
           <a:p>
             <a:fld id="{F7021451-1387-4CA6-816F-3879F97B5CBC}" type="slidenum">
               <a:rPr lang="en-US"/>
+              <a:t>2</a:t>
             </a:fld>
             <a:endParaRPr lang="en-US"/>
           </a:p>
@@ -1839,6 +1846,7 @@
           <a:p>
             <a:fld id="{F7021451-1387-4CA6-816F-3879F97B5CBC}" type="slidenum">
               <a:rPr lang="en-US"/>
+              <a:t>20</a:t>
             </a:fld>
             <a:endParaRPr lang="en-US"/>
           </a:p>
@@ -1917,6 +1925,7 @@
           <a:p>
             <a:fld id="{F7021451-1387-4CA6-816F-3879F97B5CBC}" type="slidenum">
               <a:rPr lang="en-US"/>
+              <a:t>21</a:t>
             </a:fld>
             <a:endParaRPr lang="en-US"/>
           </a:p>
@@ -1995,6 +2004,7 @@
           <a:p>
             <a:fld id="{F7021451-1387-4CA6-816F-3879F97B5CBC}" type="slidenum">
               <a:rPr lang="en-US"/>
+              <a:t>3</a:t>
             </a:fld>
             <a:endParaRPr lang="en-US"/>
           </a:p>
@@ -2073,6 +2083,7 @@
           <a:p>
             <a:fld id="{F7021451-1387-4CA6-816F-3879F97B5CBC}" type="slidenum">
               <a:rPr lang="en-US"/>
+              <a:t>4</a:t>
             </a:fld>
             <a:endParaRPr lang="en-US"/>
           </a:p>
@@ -2151,6 +2162,7 @@
           <a:p>
             <a:fld id="{F7021451-1387-4CA6-816F-3879F97B5CBC}" type="slidenum">
               <a:rPr lang="en-US"/>
+              <a:t>5</a:t>
             </a:fld>
             <a:endParaRPr lang="en-US"/>
           </a:p>
@@ -2229,6 +2241,7 @@
           <a:p>
             <a:fld id="{F7021451-1387-4CA6-816F-3879F97B5CBC}" type="slidenum">
               <a:rPr lang="en-US"/>
+              <a:t>6</a:t>
             </a:fld>
             <a:endParaRPr lang="en-US"/>
           </a:p>
@@ -2307,6 +2320,7 @@
           <a:p>
             <a:fld id="{F7021451-1387-4CA6-816F-3879F97B5CBC}" type="slidenum">
               <a:rPr lang="en-US"/>
+              <a:t>7</a:t>
             </a:fld>
             <a:endParaRPr lang="en-US"/>
           </a:p>
@@ -2385,6 +2399,7 @@
           <a:p>
             <a:fld id="{F7021451-1387-4CA6-816F-3879F97B5CBC}" type="slidenum">
               <a:rPr lang="en-US"/>
+              <a:t>8</a:t>
             </a:fld>
             <a:endParaRPr lang="en-US"/>
           </a:p>
@@ -2463,6 +2478,7 @@
           <a:p>
             <a:fld id="{F7021451-1387-4CA6-816F-3879F97B5CBC}" type="slidenum">
               <a:rPr lang="en-US"/>
+              <a:t>9</a:t>
             </a:fld>
             <a:endParaRPr lang="en-US"/>
           </a:p>
@@ -2831,6 +2847,13 @@
             <a:srgbClr val="1B998B"/>
           </a:solidFill>
         </p:spPr>
+        <p:txBody>
+          <a:bodyPr/>
+          <a:lstStyle/>
+          <a:p>
+            <a:endParaRPr lang="ko-KR" altLang="en-US"/>
+          </a:p>
+        </p:txBody>
       </p:sp>
       <p:sp>
         <p:nvSpPr>
@@ -2850,6 +2873,13 @@
             <a:srgbClr val="E8A12C"/>
           </a:solidFill>
         </p:spPr>
+        <p:txBody>
+          <a:bodyPr/>
+          <a:lstStyle/>
+          <a:p>
+            <a:endParaRPr lang="ko-KR" altLang="en-US"/>
+          </a:p>
+        </p:txBody>
       </p:sp>
       <p:sp>
         <p:nvSpPr>
@@ -3027,6 +3057,13 @@
             <a:prstDash val="solid"/>
           </a:ln>
         </p:spPr>
+        <p:txBody>
+          <a:bodyPr/>
+          <a:lstStyle/>
+          <a:p>
+            <a:endParaRPr lang="ko-KR" altLang="en-US"/>
+          </a:p>
+        </p:txBody>
       </p:sp>
       <p:sp>
         <p:nvSpPr>
@@ -3046,6 +3083,13 @@
             <a:srgbClr val="1B998B"/>
           </a:solidFill>
         </p:spPr>
+        <p:txBody>
+          <a:bodyPr/>
+          <a:lstStyle/>
+          <a:p>
+            <a:endParaRPr lang="ko-KR" altLang="en-US"/>
+          </a:p>
+        </p:txBody>
       </p:sp>
       <p:sp>
         <p:nvSpPr>
@@ -3164,6 +3208,13 @@
             <a:prstDash val="solid"/>
           </a:ln>
         </p:spPr>
+        <p:txBody>
+          <a:bodyPr/>
+          <a:lstStyle/>
+          <a:p>
+            <a:endParaRPr lang="ko-KR" altLang="en-US"/>
+          </a:p>
+        </p:txBody>
       </p:sp>
       <p:sp>
         <p:nvSpPr>
@@ -3183,6 +3234,13 @@
             <a:srgbClr val="E8A12C"/>
           </a:solidFill>
         </p:spPr>
+        <p:txBody>
+          <a:bodyPr/>
+          <a:lstStyle/>
+          <a:p>
+            <a:endParaRPr lang="ko-KR" altLang="en-US"/>
+          </a:p>
+        </p:txBody>
       </p:sp>
       <p:sp>
         <p:nvSpPr>
@@ -3301,6 +3359,13 @@
             <a:prstDash val="solid"/>
           </a:ln>
         </p:spPr>
+        <p:txBody>
+          <a:bodyPr/>
+          <a:lstStyle/>
+          <a:p>
+            <a:endParaRPr lang="ko-KR" altLang="en-US"/>
+          </a:p>
+        </p:txBody>
       </p:sp>
       <p:sp>
         <p:nvSpPr>
@@ -3320,6 +3385,13 @@
             <a:srgbClr val="5B8DEF"/>
           </a:solidFill>
         </p:spPr>
+        <p:txBody>
+          <a:bodyPr/>
+          <a:lstStyle/>
+          <a:p>
+            <a:endParaRPr lang="ko-KR" altLang="en-US"/>
+          </a:p>
+        </p:txBody>
       </p:sp>
       <p:sp>
         <p:nvSpPr>
@@ -3586,6 +3658,13 @@
             </a:outerShdw>
           </a:effectLst>
         </p:spPr>
+        <p:txBody>
+          <a:bodyPr/>
+          <a:lstStyle/>
+          <a:p>
+            <a:endParaRPr lang="ko-KR" altLang="en-US"/>
+          </a:p>
+        </p:txBody>
       </p:sp>
       <p:sp>
         <p:nvSpPr>
@@ -3605,6 +3684,13 @@
             <a:srgbClr val="C1121F"/>
           </a:solidFill>
         </p:spPr>
+        <p:txBody>
+          <a:bodyPr/>
+          <a:lstStyle/>
+          <a:p>
+            <a:endParaRPr lang="ko-KR" altLang="en-US"/>
+          </a:p>
+        </p:txBody>
       </p:sp>
       <p:sp>
         <p:nvSpPr>
@@ -3850,6 +3936,13 @@
             </a:outerShdw>
           </a:effectLst>
         </p:spPr>
+        <p:txBody>
+          <a:bodyPr/>
+          <a:lstStyle/>
+          <a:p>
+            <a:endParaRPr lang="ko-KR" altLang="en-US"/>
+          </a:p>
+        </p:txBody>
       </p:sp>
       <p:sp>
         <p:nvSpPr>
@@ -3869,6 +3962,13 @@
             <a:srgbClr val="1B998B"/>
           </a:solidFill>
         </p:spPr>
+        <p:txBody>
+          <a:bodyPr/>
+          <a:lstStyle/>
+          <a:p>
+            <a:endParaRPr lang="ko-KR" altLang="en-US"/>
+          </a:p>
+        </p:txBody>
       </p:sp>
       <p:sp>
         <p:nvSpPr>
@@ -4154,7 +4254,6 @@
               <a:rPr lang="en-US" sz="1100" dirty="0"/>
               <a:t>10</a:t>
             </a:r>
-            <a:endParaRPr lang="en-US" sz="1100" dirty="0"/>
           </a:p>
         </p:txBody>
       </p:sp>
@@ -4284,6 +4383,13 @@
             </a:outerShdw>
           </a:effectLst>
         </p:spPr>
+        <p:txBody>
+          <a:bodyPr/>
+          <a:lstStyle/>
+          <a:p>
+            <a:endParaRPr lang="ko-KR" altLang="en-US"/>
+          </a:p>
+        </p:txBody>
       </p:sp>
       <p:sp>
         <p:nvSpPr>
@@ -4661,10 +4767,34 @@
             <a:tbl>
               <a:tblPr/>
               <a:tblGrid>
-                <a:gridCol w="2743200"/>
-                <a:gridCol w="1371600"/>
-                <a:gridCol w="1371600"/>
-                <a:gridCol w="1371600"/>
+                <a:gridCol w="2743200">
+                  <a:extLst>
+                    <a:ext uri="{9D8B030D-6E8A-4147-A177-3AD203B41FA5}">
+                      <a16:colId xmlns:a16="http://schemas.microsoft.com/office/drawing/2014/main" val="20000"/>
+                    </a:ext>
+                  </a:extLst>
+                </a:gridCol>
+                <a:gridCol w="1371600">
+                  <a:extLst>
+                    <a:ext uri="{9D8B030D-6E8A-4147-A177-3AD203B41FA5}">
+                      <a16:colId xmlns:a16="http://schemas.microsoft.com/office/drawing/2014/main" val="20001"/>
+                    </a:ext>
+                  </a:extLst>
+                </a:gridCol>
+                <a:gridCol w="1371600">
+                  <a:extLst>
+                    <a:ext uri="{9D8B030D-6E8A-4147-A177-3AD203B41FA5}">
+                      <a16:colId xmlns:a16="http://schemas.microsoft.com/office/drawing/2014/main" val="20002"/>
+                    </a:ext>
+                  </a:extLst>
+                </a:gridCol>
+                <a:gridCol w="1371600">
+                  <a:extLst>
+                    <a:ext uri="{9D8B030D-6E8A-4147-A177-3AD203B41FA5}">
+                      <a16:colId xmlns:a16="http://schemas.microsoft.com/office/drawing/2014/main" val="20003"/>
+                    </a:ext>
+                  </a:extLst>
+                </a:gridCol>
               </a:tblGrid>
               <a:tr h="457200">
                 <a:tc>
@@ -4939,6 +5069,11 @@
                     </a:solidFill>
                   </a:tcPr>
                 </a:tc>
+                <a:extLst>
+                  <a:ext uri="{0D108BD9-81ED-4DB2-BD59-A6C34878D82A}">
+                    <a16:rowId xmlns:a16="http://schemas.microsoft.com/office/drawing/2014/main" val="10000"/>
+                  </a:ext>
+                </a:extLst>
               </a:tr>
               <a:tr h="457200">
                 <a:tc>
@@ -5213,6 +5348,11 @@
                     </a:solidFill>
                   </a:tcPr>
                 </a:tc>
+                <a:extLst>
+                  <a:ext uri="{0D108BD9-81ED-4DB2-BD59-A6C34878D82A}">
+                    <a16:rowId xmlns:a16="http://schemas.microsoft.com/office/drawing/2014/main" val="10001"/>
+                  </a:ext>
+                </a:extLst>
               </a:tr>
               <a:tr h="457200">
                 <a:tc>
@@ -5487,6 +5627,11 @@
                     </a:solidFill>
                   </a:tcPr>
                 </a:tc>
+                <a:extLst>
+                  <a:ext uri="{0D108BD9-81ED-4DB2-BD59-A6C34878D82A}">
+                    <a16:rowId xmlns:a16="http://schemas.microsoft.com/office/drawing/2014/main" val="10002"/>
+                  </a:ext>
+                </a:extLst>
               </a:tr>
               <a:tr h="457200">
                 <a:tc>
@@ -5761,6 +5906,11 @@
                     </a:solidFill>
                   </a:tcPr>
                 </a:tc>
+                <a:extLst>
+                  <a:ext uri="{0D108BD9-81ED-4DB2-BD59-A6C34878D82A}">
+                    <a16:rowId xmlns:a16="http://schemas.microsoft.com/office/drawing/2014/main" val="10003"/>
+                  </a:ext>
+                </a:extLst>
               </a:tr>
               <a:tr h="457200">
                 <a:tc>
@@ -6035,6 +6185,11 @@
                     </a:solidFill>
                   </a:tcPr>
                 </a:tc>
+                <a:extLst>
+                  <a:ext uri="{0D108BD9-81ED-4DB2-BD59-A6C34878D82A}">
+                    <a16:rowId xmlns:a16="http://schemas.microsoft.com/office/drawing/2014/main" val="10004"/>
+                  </a:ext>
+                </a:extLst>
               </a:tr>
             </a:tbl>
           </a:graphicData>
@@ -6103,6 +6258,13 @@
             </a:outerShdw>
           </a:effectLst>
         </p:spPr>
+        <p:txBody>
+          <a:bodyPr/>
+          <a:lstStyle/>
+          <a:p>
+            <a:endParaRPr lang="ko-KR" altLang="en-US"/>
+          </a:p>
+        </p:txBody>
       </p:sp>
       <p:sp>
         <p:nvSpPr>
@@ -6122,6 +6284,13 @@
             <a:srgbClr val="E8A12C"/>
           </a:solidFill>
         </p:spPr>
+        <p:txBody>
+          <a:bodyPr/>
+          <a:lstStyle/>
+          <a:p>
+            <a:endParaRPr lang="ko-KR" altLang="en-US"/>
+          </a:p>
+        </p:txBody>
       </p:sp>
       <p:sp>
         <p:nvSpPr>
@@ -6249,6 +6418,13 @@
             </a:outerShdw>
           </a:effectLst>
         </p:spPr>
+        <p:txBody>
+          <a:bodyPr/>
+          <a:lstStyle/>
+          <a:p>
+            <a:endParaRPr lang="ko-KR" altLang="en-US"/>
+          </a:p>
+        </p:txBody>
       </p:sp>
       <p:sp>
         <p:nvSpPr>
@@ -6268,6 +6444,13 @@
             <a:srgbClr val="1B998B"/>
           </a:solidFill>
         </p:spPr>
+        <p:txBody>
+          <a:bodyPr/>
+          <a:lstStyle/>
+          <a:p>
+            <a:endParaRPr lang="ko-KR" altLang="en-US"/>
+          </a:p>
+        </p:txBody>
       </p:sp>
       <p:sp>
         <p:nvSpPr>
@@ -6408,6 +6591,13 @@
             </a:outerShdw>
           </a:effectLst>
         </p:spPr>
+        <p:txBody>
+          <a:bodyPr/>
+          <a:lstStyle/>
+          <a:p>
+            <a:endParaRPr lang="ko-KR" altLang="en-US"/>
+          </a:p>
+        </p:txBody>
       </p:sp>
       <p:sp>
         <p:nvSpPr>
@@ -6427,6 +6617,13 @@
             <a:srgbClr val="13294B"/>
           </a:solidFill>
         </p:spPr>
+        <p:txBody>
+          <a:bodyPr/>
+          <a:lstStyle/>
+          <a:p>
+            <a:endParaRPr lang="ko-KR" altLang="en-US"/>
+          </a:p>
+        </p:txBody>
       </p:sp>
       <p:sp>
         <p:nvSpPr>
@@ -6799,7 +6996,7 @@
         <p:spPr>
           <a:xfrm>
             <a:off x="548640" y="2057400"/>
-            <a:ext cx="5362956" cy="2834640"/>
+            <a:ext cx="3042859" cy="2834640"/>
           </a:xfrm>
           <a:prstGeom prst="rect">
             <a:avLst/>
@@ -6815,6 +7012,13 @@
             </a:outerShdw>
           </a:effectLst>
         </p:spPr>
+        <p:txBody>
+          <a:bodyPr/>
+          <a:lstStyle/>
+          <a:p>
+            <a:endParaRPr lang="ko-KR" altLang="en-US"/>
+          </a:p>
+        </p:txBody>
       </p:sp>
       <p:sp>
         <p:nvSpPr>
@@ -6834,6 +7038,13 @@
             <a:srgbClr val="C1121F"/>
           </a:solidFill>
         </p:spPr>
+        <p:txBody>
+          <a:bodyPr/>
+          <a:lstStyle/>
+          <a:p>
+            <a:endParaRPr lang="ko-KR" altLang="en-US"/>
+          </a:p>
+        </p:txBody>
       </p:sp>
       <p:sp>
         <p:nvSpPr>
@@ -6882,7 +7093,7 @@
         <p:spPr>
           <a:xfrm>
             <a:off x="804672" y="2651760"/>
-            <a:ext cx="4860036" cy="2011680"/>
+            <a:ext cx="2512121" cy="2011680"/>
           </a:xfrm>
           <a:prstGeom prst="rect">
             <a:avLst/>
@@ -6965,8 +7176,8 @@
         </p:nvSpPr>
         <p:spPr>
           <a:xfrm>
-            <a:off x="6277356" y="2057400"/>
-            <a:ext cx="5362956" cy="2834640"/>
+            <a:off x="3765235" y="2057400"/>
+            <a:ext cx="2877661" cy="2834640"/>
           </a:xfrm>
           <a:prstGeom prst="rect">
             <a:avLst/>
@@ -6982,6 +7193,13 @@
             </a:outerShdw>
           </a:effectLst>
         </p:spPr>
+        <p:txBody>
+          <a:bodyPr/>
+          <a:lstStyle/>
+          <a:p>
+            <a:endParaRPr lang="ko-KR" altLang="en-US"/>
+          </a:p>
+        </p:txBody>
       </p:sp>
       <p:sp>
         <p:nvSpPr>
@@ -6991,7 +7209,7 @@
         </p:nvSpPr>
         <p:spPr>
           <a:xfrm>
-            <a:off x="6277356" y="2057400"/>
+            <a:off x="3765235" y="2057400"/>
             <a:ext cx="82296" cy="2834640"/>
           </a:xfrm>
           <a:prstGeom prst="rect">
@@ -7001,6 +7219,13 @@
             <a:srgbClr val="1B998B"/>
           </a:solidFill>
         </p:spPr>
+        <p:txBody>
+          <a:bodyPr/>
+          <a:lstStyle/>
+          <a:p>
+            <a:endParaRPr lang="ko-KR" altLang="en-US"/>
+          </a:p>
+        </p:txBody>
       </p:sp>
       <p:sp>
         <p:nvSpPr>
@@ -7010,8 +7235,8 @@
         </p:nvSpPr>
         <p:spPr>
           <a:xfrm>
-            <a:off x="6533388" y="2212848"/>
-            <a:ext cx="4905756" cy="365760"/>
+            <a:off x="4028696" y="2258568"/>
+            <a:ext cx="2067304" cy="365760"/>
           </a:xfrm>
           <a:prstGeom prst="rect">
             <a:avLst/>
@@ -7048,8 +7273,8 @@
         </p:nvSpPr>
         <p:spPr>
           <a:xfrm>
-            <a:off x="6533388" y="2651760"/>
-            <a:ext cx="4494276" cy="2011680"/>
+            <a:off x="4021267" y="2651760"/>
+            <a:ext cx="2330012" cy="2011680"/>
           </a:xfrm>
           <a:prstGeom prst="rect">
             <a:avLst/>
@@ -7149,6 +7374,13 @@
             </a:outerShdw>
           </a:effectLst>
         </p:spPr>
+        <p:txBody>
+          <a:bodyPr/>
+          <a:lstStyle/>
+          <a:p>
+            <a:endParaRPr lang="ko-KR" altLang="en-US"/>
+          </a:p>
+        </p:txBody>
       </p:sp>
       <p:sp>
         <p:nvSpPr>
@@ -7196,7 +7428,7 @@
                 <a:ea typeface="Calibri" pitchFamily="34" charset="-122"/>
                 <a:cs typeface="Calibri" pitchFamily="34" charset="-120"/>
               </a:rPr>
-              <a:t>a critical buffer region in the low teens (L* ≈ 13%) separating amplification from forced liquidation — located consistently by two methods, though imprecisely estimated.</a:t>
+              <a:t>a critical buffer region (L* ≈ 13%) separating amplification from forced liquidation — located consistently by two methods.</a:t>
             </a:r>
             <a:endParaRPr lang="en-US" sz="1350" dirty="0"/>
           </a:p>
@@ -7275,6 +7507,354 @@
               <a:t>13</a:t>
             </a:r>
             <a:endParaRPr lang="en-US" sz="1100" dirty="0"/>
+          </a:p>
+        </p:txBody>
+      </p:sp>
+      <p:sp>
+        <p:nvSpPr>
+          <p:cNvPr id="17" name="Shape 12">
+            <a:extLst>
+              <a:ext uri="{FF2B5EF4-FFF2-40B4-BE49-F238E27FC236}">
+                <a16:creationId xmlns:a16="http://schemas.microsoft.com/office/drawing/2014/main" id="{34FCE5DF-20C9-5636-A609-56D47C380EFF}"/>
+              </a:ext>
+            </a:extLst>
+          </p:cNvPr>
+          <p:cNvSpPr/>
+          <p:nvPr/>
+        </p:nvSpPr>
+        <p:spPr>
+          <a:xfrm>
+            <a:off x="6816632" y="2057400"/>
+            <a:ext cx="5193792" cy="2847104"/>
+          </a:xfrm>
+          <a:prstGeom prst="rect">
+            <a:avLst/>
+          </a:prstGeom>
+          <a:solidFill>
+            <a:srgbClr val="F4F6FA"/>
+          </a:solidFill>
+          <a:effectLst>
+            <a:outerShdw blurRad="88900" dist="38100" dir="8100000" algn="bl" rotWithShape="0">
+              <a:srgbClr val="000000">
+                <a:alpha val="13000"/>
+              </a:srgbClr>
+            </a:outerShdw>
+          </a:effectLst>
+        </p:spPr>
+        <p:txBody>
+          <a:bodyPr/>
+          <a:lstStyle/>
+          <a:p>
+            <a:endParaRPr lang="ko-KR" altLang="en-US"/>
+          </a:p>
+        </p:txBody>
+      </p:sp>
+      <p:sp>
+        <p:nvSpPr>
+          <p:cNvPr id="18" name="Shape 13">
+            <a:extLst>
+              <a:ext uri="{FF2B5EF4-FFF2-40B4-BE49-F238E27FC236}">
+                <a16:creationId xmlns:a16="http://schemas.microsoft.com/office/drawing/2014/main" id="{96B1B4A8-6414-9ABB-BD51-DB6F006AA1EF}"/>
+              </a:ext>
+            </a:extLst>
+          </p:cNvPr>
+          <p:cNvSpPr/>
+          <p:nvPr/>
+        </p:nvSpPr>
+        <p:spPr>
+          <a:xfrm>
+            <a:off x="6816632" y="2057400"/>
+            <a:ext cx="82296" cy="2847104"/>
+          </a:xfrm>
+          <a:prstGeom prst="rect">
+            <a:avLst/>
+          </a:prstGeom>
+          <a:solidFill>
+            <a:srgbClr val="E8A12C"/>
+          </a:solidFill>
+        </p:spPr>
+        <p:txBody>
+          <a:bodyPr/>
+          <a:lstStyle/>
+          <a:p>
+            <a:endParaRPr lang="ko-KR" altLang="en-US"/>
+          </a:p>
+        </p:txBody>
+      </p:sp>
+      <p:sp>
+        <p:nvSpPr>
+          <p:cNvPr id="19" name="Text 14">
+            <a:extLst>
+              <a:ext uri="{FF2B5EF4-FFF2-40B4-BE49-F238E27FC236}">
+                <a16:creationId xmlns:a16="http://schemas.microsoft.com/office/drawing/2014/main" id="{E8B88EF7-4715-5E8F-C87F-08B32656A655}"/>
+              </a:ext>
+            </a:extLst>
+          </p:cNvPr>
+          <p:cNvSpPr/>
+          <p:nvPr/>
+        </p:nvSpPr>
+        <p:spPr>
+          <a:xfrm>
+            <a:off x="7072664" y="1818477"/>
+            <a:ext cx="4736592" cy="1220187"/>
+          </a:xfrm>
+          <a:prstGeom prst="rect">
+            <a:avLst/>
+          </a:prstGeom>
+          <a:noFill/>
+        </p:spPr>
+        <p:txBody>
+          <a:bodyPr wrap="square" lIns="0" tIns="0" rIns="0" bIns="0" rtlCol="0" anchor="ctr"/>
+          <a:lstStyle/>
+          <a:p>
+            <a:pPr marL="0" indent="0">
+              <a:buNone/>
+            </a:pPr>
+            <a:r>
+              <a:rPr lang="en-US" sz="2200" b="1" dirty="0">
+                <a:solidFill>
+                  <a:srgbClr val="13294B"/>
+                </a:solidFill>
+                <a:latin typeface="Georgia" panose="02040502050405090303" pitchFamily="34" charset="0"/>
+                <a:ea typeface="Georgia" panose="02040502050405090303" pitchFamily="34" charset="-122"/>
+                <a:cs typeface="Georgia" panose="02040502050405090303" pitchFamily="34" charset="-120"/>
+              </a:rPr>
+              <a:t>L* is the point of the switch</a:t>
+            </a:r>
+            <a:endParaRPr lang="en-US" sz="2200" dirty="0"/>
+          </a:p>
+        </p:txBody>
+      </p:sp>
+      <p:sp>
+        <p:nvSpPr>
+          <p:cNvPr id="20" name="Text 15">
+            <a:extLst>
+              <a:ext uri="{FF2B5EF4-FFF2-40B4-BE49-F238E27FC236}">
+                <a16:creationId xmlns:a16="http://schemas.microsoft.com/office/drawing/2014/main" id="{0B464FF1-E1BC-FA4C-7565-37BD6B0B9788}"/>
+              </a:ext>
+            </a:extLst>
+          </p:cNvPr>
+          <p:cNvSpPr/>
+          <p:nvPr/>
+        </p:nvSpPr>
+        <p:spPr>
+          <a:xfrm>
+            <a:off x="7045232" y="2412430"/>
+            <a:ext cx="4736592" cy="1084611"/>
+          </a:xfrm>
+          <a:prstGeom prst="rect">
+            <a:avLst/>
+          </a:prstGeom>
+          <a:noFill/>
+        </p:spPr>
+        <p:txBody>
+          <a:bodyPr wrap="square" lIns="0" tIns="0" rIns="0" bIns="0" rtlCol="0" anchor="ctr"/>
+          <a:lstStyle/>
+          <a:p>
+            <a:pPr marL="0" indent="0">
+              <a:buNone/>
+            </a:pPr>
+            <a:endParaRPr lang="en-US" sz="1150" dirty="0"/>
+          </a:p>
+        </p:txBody>
+      </p:sp>
+      <p:sp>
+        <p:nvSpPr>
+          <p:cNvPr id="25" name="Text 10">
+            <a:extLst>
+              <a:ext uri="{FF2B5EF4-FFF2-40B4-BE49-F238E27FC236}">
+                <a16:creationId xmlns:a16="http://schemas.microsoft.com/office/drawing/2014/main" id="{EC6ACDE3-C373-84EE-2C2E-8D25C10C1C7A}"/>
+              </a:ext>
+            </a:extLst>
+          </p:cNvPr>
+          <p:cNvSpPr/>
+          <p:nvPr/>
+        </p:nvSpPr>
+        <p:spPr>
+          <a:xfrm>
+            <a:off x="7141244" y="2674081"/>
+            <a:ext cx="4626864" cy="2011680"/>
+          </a:xfrm>
+          <a:prstGeom prst="rect">
+            <a:avLst/>
+          </a:prstGeom>
+          <a:noFill/>
+        </p:spPr>
+        <p:txBody>
+          <a:bodyPr wrap="square" lIns="0" tIns="0" rIns="0" bIns="0" rtlCol="0" anchor="ctr"/>
+          <a:lstStyle/>
+          <a:p>
+            <a:pPr marL="342900" indent="-342900">
+              <a:spcAft>
+                <a:spcPts val="800"/>
+              </a:spcAft>
+              <a:buSzPct val="100000"/>
+              <a:buChar char="•"/>
+            </a:pPr>
+            <a:r>
+              <a:rPr lang="en-US" sz="1400" dirty="0">
+                <a:solidFill>
+                  <a:srgbClr val="33425C"/>
+                </a:solidFill>
+                <a:latin typeface="Calibri" pitchFamily="34" charset="0"/>
+                <a:ea typeface="Calibri" pitchFamily="34" charset="-122"/>
+                <a:cs typeface="Calibri" pitchFamily="34" charset="-120"/>
+              </a:rPr>
+              <a:t>Depends on the historical </a:t>
+            </a:r>
+            <a:r>
+              <a:rPr lang="en-US" sz="1400" dirty="0">
+                <a:solidFill>
+                  <a:srgbClr val="33425C"/>
+                </a:solidFill>
+                <a:highlight>
+                  <a:srgbClr val="FFFF00"/>
+                </a:highlight>
+                <a:latin typeface="Calibri" pitchFamily="34" charset="0"/>
+                <a:ea typeface="Calibri" pitchFamily="34" charset="-122"/>
+                <a:cs typeface="Calibri" pitchFamily="34" charset="-120"/>
+              </a:rPr>
+              <a:t>distribution of redemption shocks</a:t>
+            </a:r>
+            <a:r>
+              <a:rPr lang="en-US" sz="1400" dirty="0">
+                <a:solidFill>
+                  <a:srgbClr val="33425C"/>
+                </a:solidFill>
+                <a:latin typeface="Calibri" pitchFamily="34" charset="0"/>
+                <a:ea typeface="Calibri" pitchFamily="34" charset="-122"/>
+                <a:cs typeface="Calibri" pitchFamily="34" charset="-120"/>
+              </a:rPr>
+              <a:t>, the </a:t>
+            </a:r>
+            <a:r>
+              <a:rPr lang="en-US" sz="1400" dirty="0">
+                <a:solidFill>
+                  <a:srgbClr val="33425C"/>
+                </a:solidFill>
+                <a:highlight>
+                  <a:srgbClr val="FFFF00"/>
+                </a:highlight>
+                <a:latin typeface="Calibri" pitchFamily="34" charset="0"/>
+                <a:ea typeface="Calibri" pitchFamily="34" charset="-122"/>
+                <a:cs typeface="Calibri" pitchFamily="34" charset="-120"/>
+              </a:rPr>
+              <a:t>depth and liquidity of the T-bill market</a:t>
+            </a:r>
+            <a:r>
+              <a:rPr lang="en-US" sz="1400" dirty="0">
+                <a:solidFill>
+                  <a:srgbClr val="33425C"/>
+                </a:solidFill>
+                <a:latin typeface="Calibri" pitchFamily="34" charset="0"/>
+                <a:ea typeface="Calibri" pitchFamily="34" charset="-122"/>
+                <a:cs typeface="Calibri" pitchFamily="34" charset="-120"/>
+              </a:rPr>
+              <a:t>, and </a:t>
+            </a:r>
+            <a:r>
+              <a:rPr lang="en-US" sz="1400" dirty="0">
+                <a:solidFill>
+                  <a:srgbClr val="33425C"/>
+                </a:solidFill>
+                <a:highlight>
+                  <a:srgbClr val="FFFF00"/>
+                </a:highlight>
+                <a:latin typeface="Calibri" pitchFamily="34" charset="0"/>
+                <a:ea typeface="Calibri" pitchFamily="34" charset="-122"/>
+                <a:cs typeface="Calibri" pitchFamily="34" charset="-120"/>
+              </a:rPr>
+              <a:t>composition of reserves</a:t>
+            </a:r>
+            <a:r>
+              <a:rPr lang="en-US" sz="1400" dirty="0">
+                <a:solidFill>
+                  <a:srgbClr val="33425C"/>
+                </a:solidFill>
+                <a:latin typeface="Calibri" pitchFamily="34" charset="0"/>
+                <a:ea typeface="Calibri" pitchFamily="34" charset="-122"/>
+                <a:cs typeface="Calibri" pitchFamily="34" charset="-120"/>
+              </a:rPr>
+              <a:t>.</a:t>
+            </a:r>
+            <a:endParaRPr lang="en-US" sz="1400" dirty="0"/>
+          </a:p>
+          <a:p>
+            <a:pPr marL="342900" indent="-342900">
+              <a:spcAft>
+                <a:spcPts val="800"/>
+              </a:spcAft>
+              <a:buSzPct val="100000"/>
+              <a:buChar char="•"/>
+            </a:pPr>
+            <a:r>
+              <a:rPr lang="en-US" sz="1400" dirty="0">
+                <a:solidFill>
+                  <a:srgbClr val="33425C"/>
+                </a:solidFill>
+                <a:latin typeface="Calibri" pitchFamily="34" charset="0"/>
+                <a:ea typeface="Calibri" pitchFamily="34" charset="-122"/>
+                <a:cs typeface="Calibri" pitchFamily="34" charset="-120"/>
+              </a:rPr>
+              <a:t>Above L*, supply-spread relationship reflects the </a:t>
+            </a:r>
+            <a:r>
+              <a:rPr lang="en-US" sz="1400" dirty="0">
+                <a:solidFill>
+                  <a:srgbClr val="33425C"/>
+                </a:solidFill>
+                <a:highlight>
+                  <a:srgbClr val="FFFF00"/>
+                </a:highlight>
+                <a:latin typeface="Calibri" pitchFamily="34" charset="0"/>
+                <a:ea typeface="Calibri" pitchFamily="34" charset="-122"/>
+                <a:cs typeface="Calibri" pitchFamily="34" charset="-120"/>
+              </a:rPr>
+              <a:t>demand only channel. </a:t>
+            </a:r>
+          </a:p>
+          <a:p>
+            <a:pPr marL="342900" indent="-342900">
+              <a:spcAft>
+                <a:spcPts val="800"/>
+              </a:spcAft>
+              <a:buSzPct val="100000"/>
+              <a:buChar char="•"/>
+            </a:pPr>
+            <a:r>
+              <a:rPr lang="en-US" sz="1400" dirty="0">
+                <a:solidFill>
+                  <a:srgbClr val="33425C"/>
+                </a:solidFill>
+                <a:latin typeface="Calibri" pitchFamily="34" charset="0"/>
+                <a:cs typeface="Calibri" pitchFamily="34" charset="-120"/>
+              </a:rPr>
+              <a:t>Below L*, it reflects for </a:t>
+            </a:r>
+            <a:r>
+              <a:rPr lang="en-US" sz="1400" dirty="0">
+                <a:solidFill>
+                  <a:srgbClr val="33425C"/>
+                </a:solidFill>
+                <a:highlight>
+                  <a:srgbClr val="FFFF00"/>
+                </a:highlight>
+                <a:latin typeface="Calibri" pitchFamily="34" charset="0"/>
+                <a:cs typeface="Calibri" pitchFamily="34" charset="-120"/>
+              </a:rPr>
+              <a:t>forced liquidation </a:t>
+            </a:r>
+            <a:r>
+              <a:rPr lang="en-US" sz="1400" dirty="0">
+                <a:solidFill>
+                  <a:srgbClr val="33425C"/>
+                </a:solidFill>
+                <a:latin typeface="Calibri" pitchFamily="34" charset="0"/>
+                <a:cs typeface="Calibri" pitchFamily="34" charset="-120"/>
+              </a:rPr>
+              <a:t>– also changes the sign of some effects and magnitude of others. </a:t>
+            </a:r>
+            <a:endParaRPr lang="en-US" sz="1400" dirty="0"/>
           </a:p>
         </p:txBody>
       </p:sp>
@@ -7343,7 +7923,7 @@
                 <a:ea typeface="Calibri" pitchFamily="34" charset="-122"/>
                 <a:cs typeface="Calibri" pitchFamily="34" charset="-120"/>
               </a:rPr>
-              <a:t>THRESHOLD RESULT</a:t>
+              <a:t>THRESHOLD RESULT: HANSEN</a:t>
             </a:r>
             <a:endParaRPr lang="en-US" sz="1200" dirty="0"/>
           </a:p>
@@ -7434,7 +8014,7 @@
           <p:nvPr/>
         </p:nvPicPr>
         <p:blipFill>
-          <a:blip r:embed="rId1"/>
+          <a:blip r:embed="rId3"/>
           <a:stretch>
             <a:fillRect/>
           </a:stretch>
@@ -7495,7 +8075,7 @@
         </p:nvSpPr>
         <p:spPr>
           <a:xfrm>
-            <a:off x="6446520" y="1920240"/>
+            <a:off x="6446520" y="2438763"/>
             <a:ext cx="5193792" cy="960120"/>
           </a:xfrm>
           <a:prstGeom prst="rect">
@@ -7512,6 +8092,13 @@
             </a:outerShdw>
           </a:effectLst>
         </p:spPr>
+        <p:txBody>
+          <a:bodyPr/>
+          <a:lstStyle/>
+          <a:p>
+            <a:endParaRPr lang="ko-KR" altLang="en-US"/>
+          </a:p>
+        </p:txBody>
       </p:sp>
       <p:sp>
         <p:nvSpPr>
@@ -7521,7 +8108,7 @@
         </p:nvSpPr>
         <p:spPr>
           <a:xfrm>
-            <a:off x="6446520" y="1920240"/>
+            <a:off x="6446520" y="2438763"/>
             <a:ext cx="82296" cy="960120"/>
           </a:xfrm>
           <a:prstGeom prst="rect">
@@ -7531,6 +8118,13 @@
             <a:srgbClr val="1B998B"/>
           </a:solidFill>
         </p:spPr>
+        <p:txBody>
+          <a:bodyPr/>
+          <a:lstStyle/>
+          <a:p>
+            <a:endParaRPr lang="ko-KR" altLang="en-US"/>
+          </a:p>
+        </p:txBody>
       </p:sp>
       <p:sp>
         <p:nvSpPr>
@@ -7540,7 +8134,7 @@
         </p:nvSpPr>
         <p:spPr>
           <a:xfrm>
-            <a:off x="6675120" y="2029968"/>
+            <a:off x="6675120" y="2548491"/>
             <a:ext cx="4736592" cy="411480"/>
           </a:xfrm>
           <a:prstGeom prst="rect">
@@ -7578,7 +8172,7 @@
         </p:nvSpPr>
         <p:spPr>
           <a:xfrm>
-            <a:off x="6675120" y="2468880"/>
+            <a:off x="6675120" y="2987403"/>
             <a:ext cx="4736592" cy="365760"/>
           </a:xfrm>
           <a:prstGeom prst="rect">
@@ -7610,13 +8204,13 @@
       </p:sp>
       <p:sp>
         <p:nvSpPr>
-          <p:cNvPr id="11" name="Shape 8"/>
-          <p:cNvSpPr/>
-          <p:nvPr/>
-        </p:nvSpPr>
-        <p:spPr>
-          <a:xfrm>
-            <a:off x="6446520" y="2999232"/>
+          <p:cNvPr id="15" name="Shape 12"/>
+          <p:cNvSpPr/>
+          <p:nvPr/>
+        </p:nvSpPr>
+        <p:spPr>
+          <a:xfrm>
+            <a:off x="6446520" y="3658858"/>
             <a:ext cx="5193792" cy="960120"/>
           </a:xfrm>
           <a:prstGeom prst="rect">
@@ -7633,35 +8227,49 @@
             </a:outerShdw>
           </a:effectLst>
         </p:spPr>
-      </p:sp>
-      <p:sp>
-        <p:nvSpPr>
-          <p:cNvPr id="12" name="Shape 9"/>
-          <p:cNvSpPr/>
-          <p:nvPr/>
-        </p:nvSpPr>
-        <p:spPr>
-          <a:xfrm>
-            <a:off x="6446520" y="2999232"/>
+        <p:txBody>
+          <a:bodyPr/>
+          <a:lstStyle/>
+          <a:p>
+            <a:endParaRPr lang="ko-KR" altLang="en-US"/>
+          </a:p>
+        </p:txBody>
+      </p:sp>
+      <p:sp>
+        <p:nvSpPr>
+          <p:cNvPr id="16" name="Shape 13"/>
+          <p:cNvSpPr/>
+          <p:nvPr/>
+        </p:nvSpPr>
+        <p:spPr>
+          <a:xfrm>
+            <a:off x="6446520" y="3658858"/>
             <a:ext cx="82296" cy="960120"/>
           </a:xfrm>
           <a:prstGeom prst="rect">
             <a:avLst/>
           </a:prstGeom>
           <a:solidFill>
-            <a:srgbClr val="13294B"/>
+            <a:srgbClr val="E8A12C"/>
           </a:solidFill>
         </p:spPr>
-      </p:sp>
-      <p:sp>
-        <p:nvSpPr>
-          <p:cNvPr id="13" name="Text 10"/>
-          <p:cNvSpPr/>
-          <p:nvPr/>
-        </p:nvSpPr>
-        <p:spPr>
-          <a:xfrm>
-            <a:off x="6675120" y="3108960"/>
+        <p:txBody>
+          <a:bodyPr/>
+          <a:lstStyle/>
+          <a:p>
+            <a:endParaRPr lang="ko-KR" altLang="en-US"/>
+          </a:p>
+        </p:txBody>
+      </p:sp>
+      <p:sp>
+        <p:nvSpPr>
+          <p:cNvPr id="17" name="Text 14"/>
+          <p:cNvSpPr/>
+          <p:nvPr/>
+        </p:nvSpPr>
+        <p:spPr>
+          <a:xfrm>
+            <a:off x="6675120" y="3768586"/>
             <a:ext cx="4736592" cy="411480"/>
           </a:xfrm>
           <a:prstGeom prst="rect">
@@ -7685,7 +8293,7 @@
                 <a:ea typeface="Georgia" panose="02040502050405090303" pitchFamily="34" charset="-122"/>
                 <a:cs typeface="Georgia" panose="02040502050405090303" pitchFamily="34" charset="-120"/>
               </a:rPr>
-              <a:t>c* = 14.9%</a:t>
+              <a:t>p = 0.406</a:t>
             </a:r>
             <a:endParaRPr lang="en-US" sz="2200" dirty="0"/>
           </a:p>
@@ -7693,13 +8301,13 @@
       </p:sp>
       <p:sp>
         <p:nvSpPr>
-          <p:cNvPr id="14" name="Text 11"/>
-          <p:cNvSpPr/>
-          <p:nvPr/>
-        </p:nvSpPr>
-        <p:spPr>
-          <a:xfrm>
-            <a:off x="6675120" y="3547872"/>
+          <p:cNvPr id="18" name="Text 15"/>
+          <p:cNvSpPr/>
+          <p:nvPr/>
+        </p:nvSpPr>
+        <p:spPr>
+          <a:xfrm>
+            <a:off x="6675120" y="4207498"/>
             <a:ext cx="4736592" cy="365760"/>
           </a:xfrm>
           <a:prstGeom prst="rect">
@@ -7723,7 +8331,7 @@
                 <a:ea typeface="Calibri" pitchFamily="34" charset="-122"/>
                 <a:cs typeface="Calibri" pitchFamily="34" charset="-120"/>
               </a:rPr>
-              <a:t>LSTAR smooth transition — locates the same region</a:t>
+              <a:t>bootstrap; 90% CI [3.1%, 14.5%] — location robust, not precise</a:t>
             </a:r>
             <a:endParaRPr lang="en-US" sz="1150" dirty="0"/>
           </a:p>
@@ -7731,14 +8339,14 @@
       </p:sp>
       <p:sp>
         <p:nvSpPr>
-          <p:cNvPr id="15" name="Shape 12"/>
-          <p:cNvSpPr/>
-          <p:nvPr/>
-        </p:nvSpPr>
-        <p:spPr>
-          <a:xfrm>
-            <a:off x="6446520" y="4078224"/>
-            <a:ext cx="5193792" cy="960120"/>
+          <p:cNvPr id="19" name="Shape 16"/>
+          <p:cNvSpPr/>
+          <p:nvPr/>
+        </p:nvSpPr>
+        <p:spPr>
+          <a:xfrm>
+            <a:off x="548640" y="5138928"/>
+            <a:ext cx="11091672" cy="1188720"/>
           </a:xfrm>
           <a:prstGeom prst="rect">
             <a:avLst/>
@@ -7754,127 +8362,13 @@
             </a:outerShdw>
           </a:effectLst>
         </p:spPr>
-      </p:sp>
-      <p:sp>
-        <p:nvSpPr>
-          <p:cNvPr id="16" name="Shape 13"/>
-          <p:cNvSpPr/>
-          <p:nvPr/>
-        </p:nvSpPr>
-        <p:spPr>
-          <a:xfrm>
-            <a:off x="6446520" y="4078224"/>
-            <a:ext cx="82296" cy="960120"/>
-          </a:xfrm>
-          <a:prstGeom prst="rect">
-            <a:avLst/>
-          </a:prstGeom>
-          <a:solidFill>
-            <a:srgbClr val="E8A12C"/>
-          </a:solidFill>
-        </p:spPr>
-      </p:sp>
-      <p:sp>
-        <p:nvSpPr>
-          <p:cNvPr id="17" name="Text 14"/>
-          <p:cNvSpPr/>
-          <p:nvPr/>
-        </p:nvSpPr>
-        <p:spPr>
-          <a:xfrm>
-            <a:off x="6675120" y="4187952"/>
-            <a:ext cx="4736592" cy="411480"/>
-          </a:xfrm>
-          <a:prstGeom prst="rect">
-            <a:avLst/>
-          </a:prstGeom>
-          <a:noFill/>
-        </p:spPr>
-        <p:txBody>
-          <a:bodyPr wrap="square" lIns="0" tIns="0" rIns="0" bIns="0" rtlCol="0" anchor="ctr"/>
-          <a:lstStyle/>
-          <a:p>
-            <a:pPr marL="0" indent="0">
-              <a:buNone/>
-            </a:pPr>
-            <a:r>
-              <a:rPr lang="en-US" sz="2200" b="1" dirty="0">
-                <a:solidFill>
-                  <a:srgbClr val="13294B"/>
-                </a:solidFill>
-                <a:latin typeface="Georgia" panose="02040502050405090303" pitchFamily="34" charset="0"/>
-                <a:ea typeface="Georgia" panose="02040502050405090303" pitchFamily="34" charset="-122"/>
-                <a:cs typeface="Georgia" panose="02040502050405090303" pitchFamily="34" charset="-120"/>
-              </a:rPr>
-              <a:t>p = 0.406</a:t>
-            </a:r>
-            <a:endParaRPr lang="en-US" sz="2200" dirty="0"/>
-          </a:p>
-        </p:txBody>
-      </p:sp>
-      <p:sp>
-        <p:nvSpPr>
-          <p:cNvPr id="18" name="Text 15"/>
-          <p:cNvSpPr/>
-          <p:nvPr/>
-        </p:nvSpPr>
-        <p:spPr>
-          <a:xfrm>
-            <a:off x="6675120" y="4626864"/>
-            <a:ext cx="4736592" cy="365760"/>
-          </a:xfrm>
-          <a:prstGeom prst="rect">
-            <a:avLst/>
-          </a:prstGeom>
-          <a:noFill/>
-        </p:spPr>
-        <p:txBody>
-          <a:bodyPr wrap="square" lIns="0" tIns="0" rIns="0" bIns="0" rtlCol="0" anchor="ctr"/>
-          <a:lstStyle/>
-          <a:p>
-            <a:pPr marL="0" indent="0">
-              <a:buNone/>
-            </a:pPr>
-            <a:r>
-              <a:rPr lang="en-US" sz="1150" dirty="0">
-                <a:solidFill>
-                  <a:srgbClr val="33425C"/>
-                </a:solidFill>
-                <a:latin typeface="Calibri" pitchFamily="34" charset="0"/>
-                <a:ea typeface="Calibri" pitchFamily="34" charset="-122"/>
-                <a:cs typeface="Calibri" pitchFamily="34" charset="-120"/>
-              </a:rPr>
-              <a:t>bootstrap; 90% CI [3.1%, 14.5%] — location robust, not precise</a:t>
-            </a:r>
-            <a:endParaRPr lang="en-US" sz="1150" dirty="0"/>
-          </a:p>
-        </p:txBody>
-      </p:sp>
-      <p:sp>
-        <p:nvSpPr>
-          <p:cNvPr id="19" name="Shape 16"/>
-          <p:cNvSpPr/>
-          <p:nvPr/>
-        </p:nvSpPr>
-        <p:spPr>
-          <a:xfrm>
-            <a:off x="548640" y="5138928"/>
-            <a:ext cx="11091672" cy="1188720"/>
-          </a:xfrm>
-          <a:prstGeom prst="rect">
-            <a:avLst/>
-          </a:prstGeom>
-          <a:solidFill>
-            <a:srgbClr val="F4F6FA"/>
-          </a:solidFill>
-          <a:effectLst>
-            <a:outerShdw blurRad="88900" dist="38100" dir="8100000" algn="bl" rotWithShape="0">
-              <a:srgbClr val="000000">
-                <a:alpha val="13000"/>
-              </a:srgbClr>
-            </a:outerShdw>
-          </a:effectLst>
-        </p:spPr>
+        <p:txBody>
+          <a:bodyPr/>
+          <a:lstStyle/>
+          <a:p>
+            <a:endParaRPr lang="ko-KR" altLang="en-US"/>
+          </a:p>
+        </p:txBody>
       </p:sp>
       <p:sp>
         <p:nvSpPr>
@@ -7894,6 +8388,13 @@
             <a:srgbClr val="C1121F"/>
           </a:solidFill>
         </p:spPr>
+        <p:txBody>
+          <a:bodyPr/>
+          <a:lstStyle/>
+          <a:p>
+            <a:endParaRPr lang="ko-KR" altLang="en-US"/>
+          </a:p>
+        </p:txBody>
       </p:sp>
       <p:sp>
         <p:nvSpPr>
@@ -7903,7 +8404,7 @@
         </p:nvSpPr>
         <p:spPr>
           <a:xfrm>
-            <a:off x="822960" y="5248656"/>
+            <a:off x="822960" y="5376672"/>
             <a:ext cx="10543032" cy="960120"/>
           </a:xfrm>
           <a:prstGeom prst="rect">
@@ -7922,7 +8423,7 @@
               <a:buNone/>
             </a:pPr>
             <a:r>
-              <a:rPr lang="en-US" sz="1250" b="1" dirty="0">
+              <a:rPr lang="en-US" sz="1600" b="1" dirty="0">
                 <a:solidFill>
                   <a:srgbClr val="1B998B"/>
                 </a:solidFill>
@@ -7933,7 +8434,7 @@
               <a:t>Converges:  </a:t>
             </a:r>
             <a:r>
-              <a:rPr lang="en-US" sz="1250" dirty="0">
+              <a:rPr lang="en-US" sz="1600" dirty="0">
                 <a:solidFill>
                   <a:srgbClr val="33425C"/>
                 </a:solidFill>
@@ -7944,7 +8445,7 @@
               <a:t>the threshold LOCATION (≈13%) — stable across both methods, all TRIM values, every model vintage.   </a:t>
             </a:r>
             <a:br>
-              <a:rPr lang="en-US" sz="1250" dirty="0">
+              <a:rPr lang="en-US" sz="1600" dirty="0">
                 <a:solidFill>
                   <a:srgbClr val="33425C"/>
                 </a:solidFill>
@@ -7954,7 +8455,7 @@
               </a:rPr>
             </a:br>
             <a:r>
-              <a:rPr lang="en-US" sz="1250" b="1" dirty="0">
+              <a:rPr lang="en-US" sz="1600" b="1" dirty="0">
                 <a:solidFill>
                   <a:srgbClr val="C1121F"/>
                 </a:solidFill>
@@ -7965,7 +8466,7 @@
               <a:t>Does NOT converge:  </a:t>
             </a:r>
             <a:r>
-              <a:rPr lang="en-US" sz="1250" dirty="0">
+              <a:rPr lang="en-US" sz="1600" dirty="0">
                 <a:solidFill>
                   <a:srgbClr val="33425C"/>
                 </a:solidFill>
@@ -7973,10 +8474,10 @@
                 <a:ea typeface="Calibri" pitchFamily="34" charset="-122"/>
                 <a:cs typeface="Calibri" pitchFamily="34" charset="-120"/>
               </a:rPr>
-              <a:t>the regime-beta magnitudes — Hansen (hard split) and LSTAR (smooth model) estimate different objects, so do not show them as mutual corroboration.   </a:t>
+              <a:t>the regime-beta magnitudes — Hansen (hard split) and LSTAR (smooth model) estimate different objects.</a:t>
             </a:r>
             <a:br>
-              <a:rPr lang="en-US" sz="1250" dirty="0">
+              <a:rPr lang="en-US" sz="1600" dirty="0">
                 <a:solidFill>
                   <a:srgbClr val="33425C"/>
                 </a:solidFill>
@@ -7985,29 +8486,7 @@
                 <a:cs typeface="Calibri" pitchFamily="34" charset="-120"/>
               </a:rPr>
             </a:br>
-            <a:r>
-              <a:rPr lang="en-US" sz="1250" b="1" dirty="0">
-                <a:solidFill>
-                  <a:srgbClr val="13294B"/>
-                </a:solidFill>
-                <a:latin typeface="Calibri" pitchFamily="34" charset="0"/>
-                <a:ea typeface="Calibri" pitchFamily="34" charset="-122"/>
-                <a:cs typeface="Calibri" pitchFamily="34" charset="-120"/>
-              </a:rPr>
-              <a:t>Claim only:  </a:t>
-            </a:r>
-            <a:r>
-              <a:rPr lang="en-US" sz="1250" i="1" dirty="0">
-                <a:solidFill>
-                  <a:srgbClr val="33425C"/>
-                </a:solidFill>
-                <a:latin typeface="Calibri" pitchFamily="34" charset="0"/>
-                <a:ea typeface="Calibri" pitchFamily="34" charset="-122"/>
-                <a:cs typeface="Calibri" pitchFamily="34" charset="-120"/>
-              </a:rPr>
-              <a:t>“two methods locate the same fragility region near 13%.”</a:t>
-            </a:r>
-            <a:endParaRPr lang="en-US" sz="1250" dirty="0"/>
+            <a:endParaRPr lang="en-US" sz="1600" dirty="0"/>
           </a:p>
         </p:txBody>
       </p:sp>
@@ -8132,9 +8611,6 @@
           <a:bodyPr wrap="square" lIns="0" tIns="0" rIns="0" bIns="0" rtlCol="0" anchor="ctr"/>
           <a:lstStyle/>
           <a:p>
-            <a:pPr marL="0" indent="0">
-              <a:buNone/>
-            </a:pPr>
             <a:r>
               <a:rPr lang="en-US" sz="1200" b="1" kern="0" spc="200" dirty="0">
                 <a:solidFill>
@@ -8144,9 +8620,20 @@
                 <a:ea typeface="Calibri" pitchFamily="34" charset="-122"/>
                 <a:cs typeface="Calibri" pitchFamily="34" charset="-120"/>
               </a:rPr>
-              <a:t>ROBUSTNESS</a:t>
-            </a:r>
-            <a:endParaRPr lang="en-US" sz="1200" dirty="0"/>
+              <a:t>ROBUSTNESS - </a:t>
+            </a:r>
+            <a:r>
+              <a:rPr lang="en-US" altLang="ko-KR" sz="1200" b="1" kern="0" spc="200" dirty="0">
+                <a:solidFill>
+                  <a:srgbClr val="1B998B"/>
+                </a:solidFill>
+                <a:latin typeface="Calibri" pitchFamily="34" charset="0"/>
+                <a:ea typeface="Calibri" pitchFamily="34" charset="-122"/>
+                <a:cs typeface="Calibri" pitchFamily="34" charset="-120"/>
+              </a:rPr>
+              <a:t>THRESHOLD RESULT: LSTAR</a:t>
+            </a:r>
+            <a:endParaRPr lang="en-US" altLang="ko-KR" sz="1200" dirty="0"/>
           </a:p>
         </p:txBody>
       </p:sp>
@@ -8235,15 +8722,15 @@
           <p:nvPr/>
         </p:nvPicPr>
         <p:blipFill>
-          <a:blip r:embed="rId1"/>
+          <a:blip r:embed="rId3"/>
           <a:stretch>
             <a:fillRect/>
           </a:stretch>
         </p:blipFill>
         <p:spPr>
           <a:xfrm>
-            <a:off x="1705356" y="1828800"/>
-            <a:ext cx="8778240" cy="3284040"/>
+            <a:off x="3068879" y="1874521"/>
+            <a:ext cx="8495105" cy="3178116"/>
           </a:xfrm>
           <a:prstGeom prst="rect">
             <a:avLst/>
@@ -8275,6 +8762,13 @@
             </a:outerShdw>
           </a:effectLst>
         </p:spPr>
+        <p:txBody>
+          <a:bodyPr/>
+          <a:lstStyle/>
+          <a:p>
+            <a:endParaRPr lang="ko-KR" altLang="en-US"/>
+          </a:p>
+        </p:txBody>
       </p:sp>
       <p:sp>
         <p:nvSpPr>
@@ -8294,6 +8788,13 @@
             <a:srgbClr val="E8A12C"/>
           </a:solidFill>
         </p:spPr>
+        <p:txBody>
+          <a:bodyPr/>
+          <a:lstStyle/>
+          <a:p>
+            <a:endParaRPr lang="ko-KR" altLang="en-US"/>
+          </a:p>
+        </p:txBody>
       </p:sp>
       <p:sp>
         <p:nvSpPr>
@@ -8341,8 +8842,30 @@
                 <a:ea typeface="Calibri" pitchFamily="34" charset="-122"/>
                 <a:cs typeface="Calibri" pitchFamily="34" charset="-120"/>
               </a:rPr>
-              <a:t>the transition midpoint c* = 14.9% lands inside the Hansen bootstrap CI — two methods, same 13–15% region.   </a:t>
-            </a:r>
+              <a:t>the transition midpoint c* = 14.9% lands just above the Hansen bootstrap CI — two methods, </a:t>
+            </a:r>
+            <a:r>
+              <a:rPr lang="en-US" sz="1200" dirty="0">
+                <a:solidFill>
+                  <a:srgbClr val="33425C"/>
+                </a:solidFill>
+                <a:highlight>
+                  <a:srgbClr val="FFFF00"/>
+                </a:highlight>
+                <a:latin typeface="Calibri" pitchFamily="34" charset="0"/>
+                <a:ea typeface="Calibri" pitchFamily="34" charset="-122"/>
+                <a:cs typeface="Calibri" pitchFamily="34" charset="-120"/>
+              </a:rPr>
+              <a:t>same 13–15% region.   </a:t>
+            </a:r>
+          </a:p>
+          <a:p>
+            <a:pPr marL="0" indent="0">
+              <a:lnSpc>
+                <a:spcPct val="106000"/>
+              </a:lnSpc>
+              <a:buNone/>
+            </a:pPr>
             <a:r>
               <a:rPr lang="en-US" sz="1200" b="1" dirty="0">
                 <a:solidFill>
@@ -8363,7 +8886,50 @@
                 <a:ea typeface="Calibri" pitchFamily="34" charset="-122"/>
                 <a:cs typeface="Calibri" pitchFamily="34" charset="-120"/>
               </a:rPr>
-              <a:t>the per-regime betas (−1.81 / −12.59) come from a different functional form than Hansen's — treat them as the LSTAR fit, not as beta-level confirmation. The robust cross-model claim is the threshold LOCATION.</a:t>
+              <a:t>the per-regime betas (−1.81 / −12.59) come from a different functional form than Hansen's — treat them as the LSTAR fit, not as beta-level confirmation. The robust cross-model claim is the threshold </a:t>
+            </a:r>
+            <a:r>
+              <a:rPr lang="en-US" sz="1200" dirty="0">
+                <a:solidFill>
+                  <a:srgbClr val="33425C"/>
+                </a:solidFill>
+                <a:highlight>
+                  <a:srgbClr val="FFFF00"/>
+                </a:highlight>
+                <a:latin typeface="Calibri" pitchFamily="34" charset="0"/>
+                <a:ea typeface="Calibri" pitchFamily="34" charset="-122"/>
+                <a:cs typeface="Calibri" pitchFamily="34" charset="-120"/>
+              </a:rPr>
+              <a:t>LOCATION.</a:t>
+            </a:r>
+          </a:p>
+          <a:p>
+            <a:pPr>
+              <a:lnSpc>
+                <a:spcPct val="106000"/>
+              </a:lnSpc>
+            </a:pPr>
+            <a:r>
+              <a:rPr lang="en-US" altLang="ko-KR" sz="1200" b="1" dirty="0">
+                <a:solidFill>
+                  <a:srgbClr val="13294B"/>
+                </a:solidFill>
+                <a:latin typeface="Calibri" pitchFamily="34" charset="0"/>
+                <a:ea typeface="Calibri" pitchFamily="34" charset="-122"/>
+                <a:cs typeface="Calibri" pitchFamily="34" charset="-120"/>
+              </a:rPr>
+              <a:t>Claim:  </a:t>
+            </a:r>
+            <a:r>
+              <a:rPr lang="en-US" altLang="ko-KR" sz="1200" i="1" dirty="0">
+                <a:solidFill>
+                  <a:srgbClr val="33425C"/>
+                </a:solidFill>
+                <a:latin typeface="Calibri" pitchFamily="34" charset="0"/>
+                <a:ea typeface="Calibri" pitchFamily="34" charset="-122"/>
+                <a:cs typeface="Calibri" pitchFamily="34" charset="-120"/>
+              </a:rPr>
+              <a:t>“two methods locate the same fragility region near 13%.”</a:t>
             </a:r>
             <a:endParaRPr lang="en-US" sz="1200" dirty="0"/>
           </a:p>
@@ -8442,6 +9008,321 @@
               <a:t>15</a:t>
             </a:r>
             <a:endParaRPr lang="en-US" sz="1100" dirty="0"/>
+          </a:p>
+        </p:txBody>
+      </p:sp>
+      <p:sp>
+        <p:nvSpPr>
+          <p:cNvPr id="11" name="Shape 8">
+            <a:extLst>
+              <a:ext uri="{FF2B5EF4-FFF2-40B4-BE49-F238E27FC236}">
+                <a16:creationId xmlns:a16="http://schemas.microsoft.com/office/drawing/2014/main" id="{00F3DB8D-E911-06FB-2D49-D384F9C74714}"/>
+              </a:ext>
+            </a:extLst>
+          </p:cNvPr>
+          <p:cNvSpPr/>
+          <p:nvPr/>
+        </p:nvSpPr>
+        <p:spPr>
+          <a:xfrm>
+            <a:off x="204004" y="2480599"/>
+            <a:ext cx="2778339" cy="960120"/>
+          </a:xfrm>
+          <a:prstGeom prst="rect">
+            <a:avLst/>
+          </a:prstGeom>
+          <a:solidFill>
+            <a:srgbClr val="F4F6FA"/>
+          </a:solidFill>
+          <a:effectLst>
+            <a:outerShdw blurRad="88900" dist="38100" dir="8100000" algn="bl" rotWithShape="0">
+              <a:srgbClr val="000000">
+                <a:alpha val="13000"/>
+              </a:srgbClr>
+            </a:outerShdw>
+          </a:effectLst>
+        </p:spPr>
+        <p:txBody>
+          <a:bodyPr/>
+          <a:lstStyle/>
+          <a:p>
+            <a:endParaRPr lang="ko-KR" altLang="en-US"/>
+          </a:p>
+        </p:txBody>
+      </p:sp>
+      <p:sp>
+        <p:nvSpPr>
+          <p:cNvPr id="12" name="Shape 9">
+            <a:extLst>
+              <a:ext uri="{FF2B5EF4-FFF2-40B4-BE49-F238E27FC236}">
+                <a16:creationId xmlns:a16="http://schemas.microsoft.com/office/drawing/2014/main" id="{5A79590A-AF30-3C1E-151A-61507E740F57}"/>
+              </a:ext>
+            </a:extLst>
+          </p:cNvPr>
+          <p:cNvSpPr/>
+          <p:nvPr/>
+        </p:nvSpPr>
+        <p:spPr>
+          <a:xfrm>
+            <a:off x="142422" y="2480599"/>
+            <a:ext cx="82296" cy="960120"/>
+          </a:xfrm>
+          <a:prstGeom prst="rect">
+            <a:avLst/>
+          </a:prstGeom>
+          <a:solidFill>
+            <a:srgbClr val="13294B"/>
+          </a:solidFill>
+        </p:spPr>
+        <p:txBody>
+          <a:bodyPr/>
+          <a:lstStyle/>
+          <a:p>
+            <a:endParaRPr lang="ko-KR" altLang="en-US"/>
+          </a:p>
+        </p:txBody>
+      </p:sp>
+      <p:sp>
+        <p:nvSpPr>
+          <p:cNvPr id="13" name="Text 10">
+            <a:extLst>
+              <a:ext uri="{FF2B5EF4-FFF2-40B4-BE49-F238E27FC236}">
+                <a16:creationId xmlns:a16="http://schemas.microsoft.com/office/drawing/2014/main" id="{9351EC8B-D08D-4EC3-684E-CBA763BCDADA}"/>
+              </a:ext>
+            </a:extLst>
+          </p:cNvPr>
+          <p:cNvSpPr/>
+          <p:nvPr/>
+        </p:nvSpPr>
+        <p:spPr>
+          <a:xfrm>
+            <a:off x="336647" y="2572039"/>
+            <a:ext cx="2533767" cy="411480"/>
+          </a:xfrm>
+          <a:prstGeom prst="rect">
+            <a:avLst/>
+          </a:prstGeom>
+          <a:noFill/>
+        </p:spPr>
+        <p:txBody>
+          <a:bodyPr wrap="square" lIns="0" tIns="0" rIns="0" bIns="0" rtlCol="0" anchor="ctr"/>
+          <a:lstStyle/>
+          <a:p>
+            <a:pPr marL="0" indent="0">
+              <a:buNone/>
+            </a:pPr>
+            <a:r>
+              <a:rPr lang="en-US" sz="2200" b="1" dirty="0">
+                <a:solidFill>
+                  <a:srgbClr val="13294B"/>
+                </a:solidFill>
+                <a:latin typeface="Georgia" panose="02040502050405090303" pitchFamily="34" charset="0"/>
+                <a:ea typeface="Georgia" panose="02040502050405090303" pitchFamily="34" charset="-122"/>
+                <a:cs typeface="Georgia" panose="02040502050405090303" pitchFamily="34" charset="-120"/>
+              </a:rPr>
+              <a:t>c* = 14.9%</a:t>
+            </a:r>
+            <a:endParaRPr lang="en-US" sz="2200" dirty="0"/>
+          </a:p>
+        </p:txBody>
+      </p:sp>
+      <p:sp>
+        <p:nvSpPr>
+          <p:cNvPr id="14" name="Text 11">
+            <a:extLst>
+              <a:ext uri="{FF2B5EF4-FFF2-40B4-BE49-F238E27FC236}">
+                <a16:creationId xmlns:a16="http://schemas.microsoft.com/office/drawing/2014/main" id="{FD166B33-C2EA-594C-6C47-100E76262320}"/>
+              </a:ext>
+            </a:extLst>
+          </p:cNvPr>
+          <p:cNvSpPr/>
+          <p:nvPr/>
+        </p:nvSpPr>
+        <p:spPr>
+          <a:xfrm>
+            <a:off x="286300" y="3029238"/>
+            <a:ext cx="2533767" cy="365760"/>
+          </a:xfrm>
+          <a:prstGeom prst="rect">
+            <a:avLst/>
+          </a:prstGeom>
+          <a:noFill/>
+        </p:spPr>
+        <p:txBody>
+          <a:bodyPr wrap="square" lIns="0" tIns="0" rIns="0" bIns="0" rtlCol="0" anchor="ctr"/>
+          <a:lstStyle/>
+          <a:p>
+            <a:pPr marL="0" indent="0">
+              <a:buNone/>
+            </a:pPr>
+            <a:r>
+              <a:rPr lang="en-US" sz="1150" dirty="0">
+                <a:solidFill>
+                  <a:srgbClr val="33425C"/>
+                </a:solidFill>
+                <a:latin typeface="Calibri" pitchFamily="34" charset="0"/>
+                <a:ea typeface="Calibri" pitchFamily="34" charset="-122"/>
+                <a:cs typeface="Calibri" pitchFamily="34" charset="-120"/>
+              </a:rPr>
+              <a:t>LSTAR smooth transition — locates a near region</a:t>
+            </a:r>
+            <a:endParaRPr lang="en-US" sz="1150" dirty="0"/>
+          </a:p>
+        </p:txBody>
+      </p:sp>
+      <p:sp>
+        <p:nvSpPr>
+          <p:cNvPr id="15" name="Shape 12">
+            <a:extLst>
+              <a:ext uri="{FF2B5EF4-FFF2-40B4-BE49-F238E27FC236}">
+                <a16:creationId xmlns:a16="http://schemas.microsoft.com/office/drawing/2014/main" id="{C847B695-BD6F-D6B5-F4B5-979D8BD7AE0A}"/>
+              </a:ext>
+            </a:extLst>
+          </p:cNvPr>
+          <p:cNvSpPr/>
+          <p:nvPr/>
+        </p:nvSpPr>
+        <p:spPr>
+          <a:xfrm>
+            <a:off x="142422" y="3554441"/>
+            <a:ext cx="2839921" cy="960120"/>
+          </a:xfrm>
+          <a:prstGeom prst="rect">
+            <a:avLst/>
+          </a:prstGeom>
+          <a:solidFill>
+            <a:srgbClr val="F4F6FA"/>
+          </a:solidFill>
+          <a:effectLst>
+            <a:outerShdw blurRad="88900" dist="38100" dir="8100000" algn="bl" rotWithShape="0">
+              <a:srgbClr val="000000">
+                <a:alpha val="13000"/>
+              </a:srgbClr>
+            </a:outerShdw>
+          </a:effectLst>
+        </p:spPr>
+        <p:txBody>
+          <a:bodyPr/>
+          <a:lstStyle/>
+          <a:p>
+            <a:endParaRPr lang="ko-KR" altLang="en-US"/>
+          </a:p>
+        </p:txBody>
+      </p:sp>
+      <p:sp>
+        <p:nvSpPr>
+          <p:cNvPr id="16" name="Shape 13">
+            <a:extLst>
+              <a:ext uri="{FF2B5EF4-FFF2-40B4-BE49-F238E27FC236}">
+                <a16:creationId xmlns:a16="http://schemas.microsoft.com/office/drawing/2014/main" id="{5AEB9283-4706-9AFD-26BC-A9866FC9F6CB}"/>
+              </a:ext>
+            </a:extLst>
+          </p:cNvPr>
+          <p:cNvSpPr/>
+          <p:nvPr/>
+        </p:nvSpPr>
+        <p:spPr>
+          <a:xfrm>
+            <a:off x="142422" y="3554441"/>
+            <a:ext cx="45719" cy="960120"/>
+          </a:xfrm>
+          <a:prstGeom prst="rect">
+            <a:avLst/>
+          </a:prstGeom>
+          <a:solidFill>
+            <a:srgbClr val="E8A12C"/>
+          </a:solidFill>
+        </p:spPr>
+        <p:txBody>
+          <a:bodyPr/>
+          <a:lstStyle/>
+          <a:p>
+            <a:endParaRPr lang="ko-KR" altLang="en-US"/>
+          </a:p>
+        </p:txBody>
+      </p:sp>
+      <p:sp>
+        <p:nvSpPr>
+          <p:cNvPr id="17" name="Text 14">
+            <a:extLst>
+              <a:ext uri="{FF2B5EF4-FFF2-40B4-BE49-F238E27FC236}">
+                <a16:creationId xmlns:a16="http://schemas.microsoft.com/office/drawing/2014/main" id="{4F6C2E0C-59FC-908A-D251-C3ED56F8A4C7}"/>
+              </a:ext>
+            </a:extLst>
+          </p:cNvPr>
+          <p:cNvSpPr/>
+          <p:nvPr/>
+        </p:nvSpPr>
+        <p:spPr>
+          <a:xfrm>
+            <a:off x="371022" y="3664169"/>
+            <a:ext cx="2589928" cy="411480"/>
+          </a:xfrm>
+          <a:prstGeom prst="rect">
+            <a:avLst/>
+          </a:prstGeom>
+          <a:noFill/>
+        </p:spPr>
+        <p:txBody>
+          <a:bodyPr wrap="square" lIns="0" tIns="0" rIns="0" bIns="0" rtlCol="0" anchor="ctr"/>
+          <a:lstStyle/>
+          <a:p>
+            <a:pPr marL="0" indent="0">
+              <a:buNone/>
+            </a:pPr>
+            <a:r>
+              <a:rPr lang="en-US" sz="2200" b="1" dirty="0">
+                <a:solidFill>
+                  <a:srgbClr val="13294B"/>
+                </a:solidFill>
+                <a:latin typeface="Georgia" panose="02040502050405090303" pitchFamily="34" charset="0"/>
+                <a:ea typeface="Georgia" panose="02040502050405090303" pitchFamily="34" charset="-122"/>
+                <a:cs typeface="Georgia" panose="02040502050405090303" pitchFamily="34" charset="-120"/>
+              </a:rPr>
+              <a:t>p = 0.063</a:t>
+            </a:r>
+            <a:endParaRPr lang="en-US" sz="2200" dirty="0"/>
+          </a:p>
+        </p:txBody>
+      </p:sp>
+      <p:sp>
+        <p:nvSpPr>
+          <p:cNvPr id="18" name="Text 15">
+            <a:extLst>
+              <a:ext uri="{FF2B5EF4-FFF2-40B4-BE49-F238E27FC236}">
+                <a16:creationId xmlns:a16="http://schemas.microsoft.com/office/drawing/2014/main" id="{0B71220E-46B3-BB25-80CC-E00CE1B53F4F}"/>
+              </a:ext>
+            </a:extLst>
+          </p:cNvPr>
+          <p:cNvSpPr/>
+          <p:nvPr/>
+        </p:nvSpPr>
+        <p:spPr>
+          <a:xfrm>
+            <a:off x="371022" y="4103081"/>
+            <a:ext cx="2589928" cy="365760"/>
+          </a:xfrm>
+          <a:prstGeom prst="rect">
+            <a:avLst/>
+          </a:prstGeom>
+          <a:noFill/>
+        </p:spPr>
+        <p:txBody>
+          <a:bodyPr wrap="square" lIns="0" tIns="0" rIns="0" bIns="0" rtlCol="0" anchor="ctr"/>
+          <a:lstStyle/>
+          <a:p>
+            <a:r>
+              <a:rPr lang="en-US" sz="1150" dirty="0">
+                <a:solidFill>
+                  <a:srgbClr val="33425C"/>
+                </a:solidFill>
+                <a:latin typeface="Calibri" pitchFamily="34" charset="0"/>
+                <a:ea typeface="Calibri" pitchFamily="34" charset="-122"/>
+                <a:cs typeface="Calibri" pitchFamily="34" charset="-120"/>
+              </a:rPr>
+              <a:t>bootstrap; 90% CI [3.24%, 14.52%] — location robust, not precise</a:t>
+            </a:r>
+            <a:endParaRPr lang="en-US" sz="1150" dirty="0"/>
           </a:p>
         </p:txBody>
       </p:sp>
@@ -8602,19 +9483,55 @@
         </p:nvGraphicFramePr>
         <p:xfrm>
           <a:off x="548640" y="2057400"/>
-          <a:ext cx="11091672" cy="2377440"/>
+          <a:ext cx="11091670" cy="2377440"/>
         </p:xfrm>
         <a:graphic>
           <a:graphicData uri="http://schemas.openxmlformats.org/drawingml/2006/table">
             <a:tbl>
               <a:tblPr/>
               <a:tblGrid>
-                <a:gridCol w="2011680"/>
-                <a:gridCol w="1815998"/>
-                <a:gridCol w="1815998"/>
-                <a:gridCol w="1815998"/>
-                <a:gridCol w="1815998"/>
-                <a:gridCol w="1815998"/>
+                <a:gridCol w="2011680">
+                  <a:extLst>
+                    <a:ext uri="{9D8B030D-6E8A-4147-A177-3AD203B41FA5}">
+                      <a16:colId xmlns:a16="http://schemas.microsoft.com/office/drawing/2014/main" val="20000"/>
+                    </a:ext>
+                  </a:extLst>
+                </a:gridCol>
+                <a:gridCol w="1815998">
+                  <a:extLst>
+                    <a:ext uri="{9D8B030D-6E8A-4147-A177-3AD203B41FA5}">
+                      <a16:colId xmlns:a16="http://schemas.microsoft.com/office/drawing/2014/main" val="20001"/>
+                    </a:ext>
+                  </a:extLst>
+                </a:gridCol>
+                <a:gridCol w="1815998">
+                  <a:extLst>
+                    <a:ext uri="{9D8B030D-6E8A-4147-A177-3AD203B41FA5}">
+                      <a16:colId xmlns:a16="http://schemas.microsoft.com/office/drawing/2014/main" val="20002"/>
+                    </a:ext>
+                  </a:extLst>
+                </a:gridCol>
+                <a:gridCol w="1815998">
+                  <a:extLst>
+                    <a:ext uri="{9D8B030D-6E8A-4147-A177-3AD203B41FA5}">
+                      <a16:colId xmlns:a16="http://schemas.microsoft.com/office/drawing/2014/main" val="20003"/>
+                    </a:ext>
+                  </a:extLst>
+                </a:gridCol>
+                <a:gridCol w="1815998">
+                  <a:extLst>
+                    <a:ext uri="{9D8B030D-6E8A-4147-A177-3AD203B41FA5}">
+                      <a16:colId xmlns:a16="http://schemas.microsoft.com/office/drawing/2014/main" val="20004"/>
+                    </a:ext>
+                  </a:extLst>
+                </a:gridCol>
+                <a:gridCol w="1815998">
+                  <a:extLst>
+                    <a:ext uri="{9D8B030D-6E8A-4147-A177-3AD203B41FA5}">
+                      <a16:colId xmlns:a16="http://schemas.microsoft.com/office/drawing/2014/main" val="20005"/>
+                    </a:ext>
+                  </a:extLst>
+                </a:gridCol>
               </a:tblGrid>
               <a:tr h="475488">
                 <a:tc>
@@ -9025,6 +9942,11 @@
                     </a:solidFill>
                   </a:tcPr>
                 </a:tc>
+                <a:extLst>
+                  <a:ext uri="{0D108BD9-81ED-4DB2-BD59-A6C34878D82A}">
+                    <a16:rowId xmlns:a16="http://schemas.microsoft.com/office/drawing/2014/main" val="10000"/>
+                  </a:ext>
+                </a:extLst>
               </a:tr>
               <a:tr h="475488">
                 <a:tc>
@@ -9435,6 +10357,11 @@
                     </a:solidFill>
                   </a:tcPr>
                 </a:tc>
+                <a:extLst>
+                  <a:ext uri="{0D108BD9-81ED-4DB2-BD59-A6C34878D82A}">
+                    <a16:rowId xmlns:a16="http://schemas.microsoft.com/office/drawing/2014/main" val="10001"/>
+                  </a:ext>
+                </a:extLst>
               </a:tr>
               <a:tr h="475488">
                 <a:tc>
@@ -9845,6 +10772,11 @@
                     </a:solidFill>
                   </a:tcPr>
                 </a:tc>
+                <a:extLst>
+                  <a:ext uri="{0D108BD9-81ED-4DB2-BD59-A6C34878D82A}">
+                    <a16:rowId xmlns:a16="http://schemas.microsoft.com/office/drawing/2014/main" val="10002"/>
+                  </a:ext>
+                </a:extLst>
               </a:tr>
               <a:tr h="475488">
                 <a:tc>
@@ -10255,6 +11187,11 @@
                     </a:solidFill>
                   </a:tcPr>
                 </a:tc>
+                <a:extLst>
+                  <a:ext uri="{0D108BD9-81ED-4DB2-BD59-A6C34878D82A}">
+                    <a16:rowId xmlns:a16="http://schemas.microsoft.com/office/drawing/2014/main" val="10003"/>
+                  </a:ext>
+                </a:extLst>
               </a:tr>
               <a:tr h="475488">
                 <a:tc>
@@ -10665,6 +11602,11 @@
                     </a:solidFill>
                   </a:tcPr>
                 </a:tc>
+                <a:extLst>
+                  <a:ext uri="{0D108BD9-81ED-4DB2-BD59-A6C34878D82A}">
+                    <a16:rowId xmlns:a16="http://schemas.microsoft.com/office/drawing/2014/main" val="10004"/>
+                  </a:ext>
+                </a:extLst>
               </a:tr>
             </a:tbl>
           </a:graphicData>
@@ -10695,6 +11637,13 @@
             </a:outerShdw>
           </a:effectLst>
         </p:spPr>
+        <p:txBody>
+          <a:bodyPr/>
+          <a:lstStyle/>
+          <a:p>
+            <a:endParaRPr lang="ko-KR" altLang="en-US"/>
+          </a:p>
+        </p:txBody>
       </p:sp>
       <p:sp>
         <p:nvSpPr>
@@ -10714,6 +11663,13 @@
             <a:srgbClr val="1B998B"/>
           </a:solidFill>
         </p:spPr>
+        <p:txBody>
+          <a:bodyPr/>
+          <a:lstStyle/>
+          <a:p>
+            <a:endParaRPr lang="ko-KR" altLang="en-US"/>
+          </a:p>
+        </p:txBody>
       </p:sp>
       <p:sp>
         <p:nvSpPr>
@@ -10999,7 +11955,7 @@
           <p:nvPr/>
         </p:nvPicPr>
         <p:blipFill>
-          <a:blip r:embed="rId1"/>
+          <a:blip r:embed="rId3"/>
           <a:stretch>
             <a:fillRect/>
           </a:stretch>
@@ -11023,7 +11979,7 @@
           <p:nvPr/>
         </p:nvPicPr>
         <p:blipFill>
-          <a:blip r:embed="rId2"/>
+          <a:blip r:embed="rId4"/>
           <a:stretch>
             <a:fillRect/>
           </a:stretch>
@@ -11063,6 +12019,13 @@
             </a:outerShdw>
           </a:effectLst>
         </p:spPr>
+        <p:txBody>
+          <a:bodyPr/>
+          <a:lstStyle/>
+          <a:p>
+            <a:endParaRPr lang="ko-KR" altLang="en-US"/>
+          </a:p>
+        </p:txBody>
       </p:sp>
       <p:sp>
         <p:nvSpPr>
@@ -11082,6 +12045,13 @@
             <a:srgbClr val="C1121F"/>
           </a:solidFill>
         </p:spPr>
+        <p:txBody>
+          <a:bodyPr/>
+          <a:lstStyle/>
+          <a:p>
+            <a:endParaRPr lang="ko-KR" altLang="en-US"/>
+          </a:p>
+        </p:txBody>
       </p:sp>
       <p:sp>
         <p:nvSpPr>
@@ -11156,18 +12126,7 @@
                 <a:ea typeface="Calibri" pitchFamily="34" charset="-122"/>
                 <a:cs typeface="Calibri" pitchFamily="34" charset="-120"/>
               </a:rPr>
-              <a:t>Only 3 events; FOMC contamination in 2 of 3.   </a:t>
-            </a:r>
-            <a:r>
-              <a:rPr lang="en-US" sz="1250" dirty="0">
-                <a:solidFill>
-                  <a:srgbClr val="33425C"/>
-                </a:solidFill>
-                <a:latin typeface="Calibri" pitchFamily="34" charset="0"/>
-                <a:ea typeface="Calibri" pitchFamily="34" charset="-122"/>
-                <a:cs typeface="Calibri" pitchFamily="34" charset="-120"/>
-              </a:rPr>
-              <a:t>All CARs individually insignificant (−41 / +23 / −27 bps).   </a:t>
+              <a:t>Only 3 events; FOMC contamination in 2 of 3.   All CARs individually insignificant (−41 / +23 / −27 bps).   </a:t>
             </a:r>
             <a:endParaRPr lang="en-US" sz="1250" dirty="0"/>
           </a:p>
@@ -11187,18 +12146,7 @@
                 <a:ea typeface="Calibri" pitchFamily="34" charset="-122"/>
                 <a:cs typeface="Calibri" pitchFamily="34" charset="-120"/>
               </a:rPr>
-              <a:t>Placebo ratio 7.0× — suggestive, not individually significant.   </a:t>
-            </a:r>
-            <a:r>
-              <a:rPr lang="en-US" sz="1250" dirty="0">
-                <a:solidFill>
-                  <a:srgbClr val="33425C"/>
-                </a:solidFill>
-                <a:latin typeface="Calibri" pitchFamily="34" charset="0"/>
-                <a:ea typeface="Calibri" pitchFamily="34" charset="-122"/>
-                <a:cs typeface="Calibri" pitchFamily="34" charset="-120"/>
-              </a:rPr>
-              <a:t>Story has shifted across re-runs — too unstable to be evidence.</a:t>
+              <a:t>Placebo ratio 7.0× — suggestive, not individually significant.   Story has shifted across re-runs — too unstable to be evidence.</a:t>
             </a:r>
             <a:endParaRPr lang="en-US" sz="1250" dirty="0"/>
           </a:p>
@@ -11452,6 +12400,13 @@
             </a:outerShdw>
           </a:effectLst>
         </p:spPr>
+        <p:txBody>
+          <a:bodyPr/>
+          <a:lstStyle/>
+          <a:p>
+            <a:endParaRPr lang="ko-KR" altLang="en-US"/>
+          </a:p>
+        </p:txBody>
       </p:sp>
       <p:sp>
         <p:nvSpPr>
@@ -11471,6 +12426,13 @@
             <a:srgbClr val="13294B"/>
           </a:solidFill>
         </p:spPr>
+        <p:txBody>
+          <a:bodyPr/>
+          <a:lstStyle/>
+          <a:p>
+            <a:endParaRPr lang="ko-KR" altLang="en-US"/>
+          </a:p>
+        </p:txBody>
       </p:sp>
       <p:sp>
         <p:nvSpPr>
@@ -11576,6 +12538,13 @@
             </a:outerShdw>
           </a:effectLst>
         </p:spPr>
+        <p:txBody>
+          <a:bodyPr/>
+          <a:lstStyle/>
+          <a:p>
+            <a:endParaRPr lang="ko-KR" altLang="en-US"/>
+          </a:p>
+        </p:txBody>
       </p:sp>
       <p:sp>
         <p:nvSpPr>
@@ -11595,6 +12564,13 @@
             <a:srgbClr val="1B998B"/>
           </a:solidFill>
         </p:spPr>
+        <p:txBody>
+          <a:bodyPr/>
+          <a:lstStyle/>
+          <a:p>
+            <a:endParaRPr lang="ko-KR" altLang="en-US"/>
+          </a:p>
+        </p:txBody>
       </p:sp>
       <p:sp>
         <p:nvSpPr>
@@ -11700,6 +12676,13 @@
             </a:outerShdw>
           </a:effectLst>
         </p:spPr>
+        <p:txBody>
+          <a:bodyPr/>
+          <a:lstStyle/>
+          <a:p>
+            <a:endParaRPr lang="ko-KR" altLang="en-US"/>
+          </a:p>
+        </p:txBody>
       </p:sp>
       <p:sp>
         <p:nvSpPr>
@@ -11719,6 +12702,13 @@
             <a:srgbClr val="E8A12C"/>
           </a:solidFill>
         </p:spPr>
+        <p:txBody>
+          <a:bodyPr/>
+          <a:lstStyle/>
+          <a:p>
+            <a:endParaRPr lang="ko-KR" altLang="en-US"/>
+          </a:p>
+        </p:txBody>
       </p:sp>
       <p:sp>
         <p:nvSpPr>
@@ -11824,6 +12814,13 @@
             </a:outerShdw>
           </a:effectLst>
         </p:spPr>
+        <p:txBody>
+          <a:bodyPr/>
+          <a:lstStyle/>
+          <a:p>
+            <a:endParaRPr lang="ko-KR" altLang="en-US"/>
+          </a:p>
+        </p:txBody>
       </p:sp>
       <p:sp>
         <p:nvSpPr>
@@ -12136,6 +13133,13 @@
             </a:outerShdw>
           </a:effectLst>
         </p:spPr>
+        <p:txBody>
+          <a:bodyPr/>
+          <a:lstStyle/>
+          <a:p>
+            <a:endParaRPr lang="ko-KR" altLang="en-US"/>
+          </a:p>
+        </p:txBody>
       </p:sp>
       <p:sp>
         <p:nvSpPr>
@@ -12155,6 +13159,13 @@
             <a:srgbClr val="1B998B"/>
           </a:solidFill>
         </p:spPr>
+        <p:txBody>
+          <a:bodyPr/>
+          <a:lstStyle/>
+          <a:p>
+            <a:endParaRPr lang="ko-KR" altLang="en-US"/>
+          </a:p>
+        </p:txBody>
       </p:sp>
       <p:sp>
         <p:nvSpPr>
@@ -12174,6 +13185,13 @@
             <a:srgbClr val="1B998B"/>
           </a:solidFill>
         </p:spPr>
+        <p:txBody>
+          <a:bodyPr/>
+          <a:lstStyle/>
+          <a:p>
+            <a:endParaRPr lang="ko-KR" altLang="en-US"/>
+          </a:p>
+        </p:txBody>
       </p:sp>
       <p:sp>
         <p:nvSpPr>
@@ -12360,6 +13378,13 @@
             </a:outerShdw>
           </a:effectLst>
         </p:spPr>
+        <p:txBody>
+          <a:bodyPr/>
+          <a:lstStyle/>
+          <a:p>
+            <a:endParaRPr lang="ko-KR" altLang="en-US"/>
+          </a:p>
+        </p:txBody>
       </p:sp>
       <p:sp>
         <p:nvSpPr>
@@ -12379,6 +13404,13 @@
             <a:srgbClr val="5B8DEF"/>
           </a:solidFill>
         </p:spPr>
+        <p:txBody>
+          <a:bodyPr/>
+          <a:lstStyle/>
+          <a:p>
+            <a:endParaRPr lang="ko-KR" altLang="en-US"/>
+          </a:p>
+        </p:txBody>
       </p:sp>
       <p:sp>
         <p:nvSpPr>
@@ -12398,6 +13430,13 @@
             <a:srgbClr val="5B8DEF"/>
           </a:solidFill>
         </p:spPr>
+        <p:txBody>
+          <a:bodyPr/>
+          <a:lstStyle/>
+          <a:p>
+            <a:endParaRPr lang="ko-KR" altLang="en-US"/>
+          </a:p>
+        </p:txBody>
       </p:sp>
       <p:sp>
         <p:nvSpPr>
@@ -12584,6 +13623,13 @@
             </a:outerShdw>
           </a:effectLst>
         </p:spPr>
+        <p:txBody>
+          <a:bodyPr/>
+          <a:lstStyle/>
+          <a:p>
+            <a:endParaRPr lang="ko-KR" altLang="en-US"/>
+          </a:p>
+        </p:txBody>
       </p:sp>
       <p:sp>
         <p:nvSpPr>
@@ -12603,6 +13649,13 @@
             <a:srgbClr val="E8A12C"/>
           </a:solidFill>
         </p:spPr>
+        <p:txBody>
+          <a:bodyPr/>
+          <a:lstStyle/>
+          <a:p>
+            <a:endParaRPr lang="ko-KR" altLang="en-US"/>
+          </a:p>
+        </p:txBody>
       </p:sp>
       <p:sp>
         <p:nvSpPr>
@@ -12622,6 +13675,13 @@
             <a:srgbClr val="E8A12C"/>
           </a:solidFill>
         </p:spPr>
+        <p:txBody>
+          <a:bodyPr/>
+          <a:lstStyle/>
+          <a:p>
+            <a:endParaRPr lang="ko-KR" altLang="en-US"/>
+          </a:p>
+        </p:txBody>
       </p:sp>
       <p:sp>
         <p:nvSpPr>
@@ -13069,6 +14129,13 @@
             </a:outerShdw>
           </a:effectLst>
         </p:spPr>
+        <p:txBody>
+          <a:bodyPr/>
+          <a:lstStyle/>
+          <a:p>
+            <a:endParaRPr lang="ko-KR" altLang="en-US"/>
+          </a:p>
+        </p:txBody>
       </p:sp>
       <p:sp>
         <p:nvSpPr>
@@ -13088,6 +14155,13 @@
             <a:srgbClr val="1B998B"/>
           </a:solidFill>
         </p:spPr>
+        <p:txBody>
+          <a:bodyPr/>
+          <a:lstStyle/>
+          <a:p>
+            <a:endParaRPr lang="ko-KR" altLang="en-US"/>
+          </a:p>
+        </p:txBody>
       </p:sp>
       <p:sp>
         <p:nvSpPr>
@@ -13114,6 +14188,13 @@
             </a:outerShdw>
           </a:effectLst>
         </p:spPr>
+        <p:txBody>
+          <a:bodyPr/>
+          <a:lstStyle/>
+          <a:p>
+            <a:endParaRPr lang="ko-KR" altLang="en-US"/>
+          </a:p>
+        </p:txBody>
       </p:sp>
       <p:sp>
         <p:nvSpPr>
@@ -13133,6 +14214,13 @@
             <a:srgbClr val="13294B"/>
           </a:solidFill>
         </p:spPr>
+        <p:txBody>
+          <a:bodyPr/>
+          <a:lstStyle/>
+          <a:p>
+            <a:endParaRPr lang="ko-KR" altLang="en-US"/>
+          </a:p>
+        </p:txBody>
       </p:sp>
       <p:sp>
         <p:nvSpPr>
@@ -13159,6 +14247,13 @@
             </a:outerShdw>
           </a:effectLst>
         </p:spPr>
+        <p:txBody>
+          <a:bodyPr/>
+          <a:lstStyle/>
+          <a:p>
+            <a:endParaRPr lang="ko-KR" altLang="en-US"/>
+          </a:p>
+        </p:txBody>
       </p:sp>
       <p:sp>
         <p:nvSpPr>
@@ -13178,6 +14273,13 @@
             <a:srgbClr val="E8A12C"/>
           </a:solidFill>
         </p:spPr>
+        <p:txBody>
+          <a:bodyPr/>
+          <a:lstStyle/>
+          <a:p>
+            <a:endParaRPr lang="ko-KR" altLang="en-US"/>
+          </a:p>
+        </p:txBody>
       </p:sp>
       <p:sp>
         <p:nvSpPr>
@@ -13664,6 +14766,13 @@
             </a:outerShdw>
           </a:effectLst>
         </p:spPr>
+        <p:txBody>
+          <a:bodyPr/>
+          <a:lstStyle/>
+          <a:p>
+            <a:endParaRPr lang="ko-KR" altLang="en-US"/>
+          </a:p>
+        </p:txBody>
       </p:sp>
       <p:sp>
         <p:nvSpPr>
@@ -13683,6 +14792,13 @@
             <a:srgbClr val="C1121F"/>
           </a:solidFill>
         </p:spPr>
+        <p:txBody>
+          <a:bodyPr/>
+          <a:lstStyle/>
+          <a:p>
+            <a:endParaRPr lang="ko-KR" altLang="en-US"/>
+          </a:p>
+        </p:txBody>
       </p:sp>
       <p:sp>
         <p:nvSpPr>
@@ -13894,6 +15010,13 @@
             </a:outerShdw>
           </a:effectLst>
         </p:spPr>
+        <p:txBody>
+          <a:bodyPr/>
+          <a:lstStyle/>
+          <a:p>
+            <a:endParaRPr lang="ko-KR" altLang="en-US"/>
+          </a:p>
+        </p:txBody>
       </p:sp>
       <p:sp>
         <p:nvSpPr>
@@ -13913,6 +15036,13 @@
             <a:srgbClr val="1B998B"/>
           </a:solidFill>
         </p:spPr>
+        <p:txBody>
+          <a:bodyPr/>
+          <a:lstStyle/>
+          <a:p>
+            <a:endParaRPr lang="ko-KR" altLang="en-US"/>
+          </a:p>
+        </p:txBody>
       </p:sp>
       <p:sp>
         <p:nvSpPr>
@@ -14143,7 +15273,6 @@
               <a:rPr lang="en-US" sz="1100" dirty="0"/>
               <a:t>20</a:t>
             </a:r>
-            <a:endParaRPr lang="en-US" sz="1100" dirty="0"/>
           </a:p>
         </p:txBody>
       </p:sp>
@@ -14198,6 +15327,13 @@
             <a:srgbClr val="1B998B"/>
           </a:solidFill>
         </p:spPr>
+        <p:txBody>
+          <a:bodyPr/>
+          <a:lstStyle/>
+          <a:p>
+            <a:endParaRPr lang="ko-KR" altLang="en-US"/>
+          </a:p>
+        </p:txBody>
       </p:sp>
       <p:sp>
         <p:nvSpPr>
@@ -14217,6 +15353,13 @@
             <a:srgbClr val="E8A12C"/>
           </a:solidFill>
         </p:spPr>
+        <p:txBody>
+          <a:bodyPr/>
+          <a:lstStyle/>
+          <a:p>
+            <a:endParaRPr lang="ko-KR" altLang="en-US"/>
+          </a:p>
+        </p:txBody>
       </p:sp>
       <p:sp>
         <p:nvSpPr>
@@ -14580,6 +15723,13 @@
             </a:outerShdw>
           </a:effectLst>
         </p:spPr>
+        <p:txBody>
+          <a:bodyPr/>
+          <a:lstStyle/>
+          <a:p>
+            <a:endParaRPr lang="ko-KR" altLang="en-US"/>
+          </a:p>
+        </p:txBody>
       </p:sp>
       <p:sp>
         <p:nvSpPr>
@@ -14599,6 +15749,13 @@
             <a:srgbClr val="E8A12C"/>
           </a:solidFill>
         </p:spPr>
+        <p:txBody>
+          <a:bodyPr/>
+          <a:lstStyle/>
+          <a:p>
+            <a:endParaRPr lang="ko-KR" altLang="en-US"/>
+          </a:p>
+        </p:txBody>
       </p:sp>
       <p:sp>
         <p:nvSpPr>
@@ -14704,6 +15861,13 @@
             </a:outerShdw>
           </a:effectLst>
         </p:spPr>
+        <p:txBody>
+          <a:bodyPr/>
+          <a:lstStyle/>
+          <a:p>
+            <a:endParaRPr lang="ko-KR" altLang="en-US"/>
+          </a:p>
+        </p:txBody>
       </p:sp>
       <p:sp>
         <p:nvSpPr>
@@ -14723,6 +15887,13 @@
             <a:srgbClr val="1B998B"/>
           </a:solidFill>
         </p:spPr>
+        <p:txBody>
+          <a:bodyPr/>
+          <a:lstStyle/>
+          <a:p>
+            <a:endParaRPr lang="ko-KR" altLang="en-US"/>
+          </a:p>
+        </p:txBody>
       </p:sp>
       <p:sp>
         <p:nvSpPr>
@@ -15086,6 +16257,13 @@
             </a:outerShdw>
           </a:effectLst>
         </p:spPr>
+        <p:txBody>
+          <a:bodyPr/>
+          <a:lstStyle/>
+          <a:p>
+            <a:endParaRPr lang="ko-KR" altLang="en-US"/>
+          </a:p>
+        </p:txBody>
       </p:sp>
       <p:sp>
         <p:nvSpPr>
@@ -15105,6 +16283,13 @@
             <a:srgbClr val="1B998B"/>
           </a:solidFill>
         </p:spPr>
+        <p:txBody>
+          <a:bodyPr/>
+          <a:lstStyle/>
+          <a:p>
+            <a:endParaRPr lang="ko-KR" altLang="en-US"/>
+          </a:p>
+        </p:txBody>
       </p:sp>
       <p:sp>
         <p:nvSpPr>
@@ -15138,18 +16323,7 @@
                 <a:ea typeface="Calibri" pitchFamily="34" charset="-122"/>
                 <a:cs typeface="Calibri" pitchFamily="34" charset="-120"/>
               </a:rPr>
-              <a:t>NORMAL TIMES   </a:t>
-            </a:r>
-            <a:r>
-              <a:rPr lang="en-US" sz="1500" b="1" dirty="0">
-                <a:solidFill>
-                  <a:srgbClr val="1B998B"/>
-                </a:solidFill>
-                <a:latin typeface="Calibri" pitchFamily="34" charset="0"/>
-                <a:ea typeface="Calibri" pitchFamily="34" charset="-122"/>
-                <a:cs typeface="Calibri" pitchFamily="34" charset="-120"/>
-              </a:rPr>
-              <a:t>✓</a:t>
+              <a:t>NORMAL TIMES   ✓</a:t>
             </a:r>
             <a:endParaRPr lang="en-US" sz="1500" dirty="0"/>
           </a:p>
@@ -15285,6 +16459,13 @@
             </a:outerShdw>
           </a:effectLst>
         </p:spPr>
+        <p:txBody>
+          <a:bodyPr/>
+          <a:lstStyle/>
+          <a:p>
+            <a:endParaRPr lang="ko-KR" altLang="en-US"/>
+          </a:p>
+        </p:txBody>
       </p:sp>
       <p:sp>
         <p:nvSpPr>
@@ -15304,6 +16485,13 @@
             <a:srgbClr val="C1121F"/>
           </a:solidFill>
         </p:spPr>
+        <p:txBody>
+          <a:bodyPr/>
+          <a:lstStyle/>
+          <a:p>
+            <a:endParaRPr lang="ko-KR" altLang="en-US"/>
+          </a:p>
+        </p:txBody>
       </p:sp>
       <p:sp>
         <p:nvSpPr>
@@ -15337,18 +16525,7 @@
                 <a:ea typeface="Calibri" pitchFamily="34" charset="-122"/>
                 <a:cs typeface="Calibri" pitchFamily="34" charset="-120"/>
               </a:rPr>
-              <a:t>RUN SCENARIO   </a:t>
-            </a:r>
-            <a:r>
-              <a:rPr lang="en-US" sz="1500" b="1" dirty="0">
-                <a:solidFill>
-                  <a:srgbClr val="C1121F"/>
-                </a:solidFill>
-                <a:latin typeface="Calibri" pitchFamily="34" charset="0"/>
-                <a:ea typeface="Calibri" pitchFamily="34" charset="-122"/>
-                <a:cs typeface="Calibri" pitchFamily="34" charset="-120"/>
-              </a:rPr>
-              <a:t>✗</a:t>
+              <a:t>RUN SCENARIO   ✗</a:t>
             </a:r>
             <a:endParaRPr lang="en-US" sz="1500" dirty="0"/>
           </a:p>
@@ -15484,6 +16661,13 @@
             </a:outerShdw>
           </a:effectLst>
         </p:spPr>
+        <p:txBody>
+          <a:bodyPr/>
+          <a:lstStyle/>
+          <a:p>
+            <a:endParaRPr lang="ko-KR" altLang="en-US"/>
+          </a:p>
+        </p:txBody>
       </p:sp>
       <p:sp>
         <p:nvSpPr>
@@ -15881,6 +17065,13 @@
             </a:outerShdw>
           </a:effectLst>
         </p:spPr>
+        <p:txBody>
+          <a:bodyPr/>
+          <a:lstStyle/>
+          <a:p>
+            <a:endParaRPr lang="ko-KR" altLang="en-US"/>
+          </a:p>
+        </p:txBody>
       </p:sp>
       <p:sp>
         <p:nvSpPr>
@@ -15914,10 +17105,10 @@
                 <a:ea typeface="Georgia" panose="02040502050405090303" pitchFamily="34" charset="-122"/>
                 <a:cs typeface="Georgia" panose="02040502050405090303" pitchFamily="34" charset="-120"/>
               </a:rPr>
-              <a:t>D*(Ñ*, S, θ, L)  =  </a:t>
-            </a:r>
-            <a:r>
-              <a:rPr lang="en-US" sz="1800" b="1" dirty="0">
+              <a:t>D*(Ñ*, S, </a:t>
+            </a:r>
+            <a:r>
+              <a:rPr lang="en-US" sz="1800" b="1">
                 <a:solidFill>
                   <a:srgbClr val="13294B"/>
                 </a:solidFill>
@@ -15925,7 +17116,18 @@
                 <a:ea typeface="Georgia" panose="02040502050405090303" pitchFamily="34" charset="-122"/>
                 <a:cs typeface="Georgia" panose="02040502050405090303" pitchFamily="34" charset="-120"/>
               </a:rPr>
-              <a:t>D*</a:t>
+              <a:t>θ, </a:t>
+            </a:r>
+            <a:r>
+              <a:rPr lang="en-US" sz="1800" b="1" dirty="0">
+                <a:solidFill>
+                  <a:srgbClr val="13294B"/>
+                </a:solidFill>
+                <a:latin typeface="Georgia" panose="02040502050405090303" pitchFamily="34" charset="0"/>
+                <a:ea typeface="Georgia" panose="02040502050405090303" pitchFamily="34" charset="-122"/>
+                <a:cs typeface="Georgia" panose="02040502050405090303" pitchFamily="34" charset="-120"/>
+              </a:rPr>
+              <a:t>L)  =  D*</a:t>
             </a:r>
             <a:r>
               <a:rPr lang="en-US" sz="1100" b="1" dirty="0">
@@ -16082,6 +17284,13 @@
             </a:outerShdw>
           </a:effectLst>
         </p:spPr>
+        <p:txBody>
+          <a:bodyPr/>
+          <a:lstStyle/>
+          <a:p>
+            <a:endParaRPr lang="ko-KR" altLang="en-US"/>
+          </a:p>
+        </p:txBody>
       </p:sp>
       <p:sp>
         <p:nvSpPr>
@@ -16101,6 +17310,13 @@
             <a:srgbClr val="1B998B"/>
           </a:solidFill>
         </p:spPr>
+        <p:txBody>
+          <a:bodyPr/>
+          <a:lstStyle/>
+          <a:p>
+            <a:endParaRPr lang="ko-KR" altLang="en-US"/>
+          </a:p>
+        </p:txBody>
       </p:sp>
       <p:sp>
         <p:nvSpPr>
@@ -16246,6 +17462,13 @@
             </a:outerShdw>
           </a:effectLst>
         </p:spPr>
+        <p:txBody>
+          <a:bodyPr/>
+          <a:lstStyle/>
+          <a:p>
+            <a:endParaRPr lang="ko-KR" altLang="en-US"/>
+          </a:p>
+        </p:txBody>
       </p:sp>
       <p:sp>
         <p:nvSpPr>
@@ -16265,6 +17488,13 @@
             <a:srgbClr val="E8A12C"/>
           </a:solidFill>
         </p:spPr>
+        <p:txBody>
+          <a:bodyPr/>
+          <a:lstStyle/>
+          <a:p>
+            <a:endParaRPr lang="ko-KR" altLang="en-US"/>
+          </a:p>
+        </p:txBody>
       </p:sp>
       <p:sp>
         <p:nvSpPr>
@@ -16541,7 +17771,7 @@
           <p:nvPr/>
         </p:nvPicPr>
         <p:blipFill>
-          <a:blip r:embed="rId1"/>
+          <a:blip r:embed="rId3"/>
           <a:stretch>
             <a:fillRect/>
           </a:stretch>
@@ -16690,6 +17920,13 @@
             </a:outerShdw>
           </a:effectLst>
         </p:spPr>
+        <p:txBody>
+          <a:bodyPr/>
+          <a:lstStyle/>
+          <a:p>
+            <a:endParaRPr lang="ko-KR" altLang="en-US"/>
+          </a:p>
+        </p:txBody>
       </p:sp>
       <p:sp>
         <p:nvSpPr>
@@ -16709,6 +17946,13 @@
             <a:srgbClr val="13294B"/>
           </a:solidFill>
         </p:spPr>
+        <p:txBody>
+          <a:bodyPr/>
+          <a:lstStyle/>
+          <a:p>
+            <a:endParaRPr lang="ko-KR" altLang="en-US"/>
+          </a:p>
+        </p:txBody>
       </p:sp>
       <p:sp>
         <p:nvSpPr>
@@ -16871,6 +18115,13 @@
             </a:outerShdw>
           </a:effectLst>
         </p:spPr>
+        <p:txBody>
+          <a:bodyPr/>
+          <a:lstStyle/>
+          <a:p>
+            <a:endParaRPr lang="ko-KR" altLang="en-US"/>
+          </a:p>
+        </p:txBody>
       </p:sp>
       <p:sp>
         <p:nvSpPr>
@@ -16890,6 +18141,13 @@
             <a:srgbClr val="13294B"/>
           </a:solidFill>
         </p:spPr>
+        <p:txBody>
+          <a:bodyPr/>
+          <a:lstStyle/>
+          <a:p>
+            <a:endParaRPr lang="ko-KR" altLang="en-US"/>
+          </a:p>
+        </p:txBody>
       </p:sp>
       <p:sp>
         <p:nvSpPr>
@@ -17052,6 +18310,13 @@
             </a:outerShdw>
           </a:effectLst>
         </p:spPr>
+        <p:txBody>
+          <a:bodyPr/>
+          <a:lstStyle/>
+          <a:p>
+            <a:endParaRPr lang="ko-KR" altLang="en-US"/>
+          </a:p>
+        </p:txBody>
       </p:sp>
       <p:sp>
         <p:nvSpPr>
@@ -17071,6 +18336,13 @@
             <a:srgbClr val="13294B"/>
           </a:solidFill>
         </p:spPr>
+        <p:txBody>
+          <a:bodyPr/>
+          <a:lstStyle/>
+          <a:p>
+            <a:endParaRPr lang="ko-KR" altLang="en-US"/>
+          </a:p>
+        </p:txBody>
       </p:sp>
       <p:sp>
         <p:nvSpPr>
@@ -17233,6 +18505,13 @@
             </a:outerShdw>
           </a:effectLst>
         </p:spPr>
+        <p:txBody>
+          <a:bodyPr/>
+          <a:lstStyle/>
+          <a:p>
+            <a:endParaRPr lang="ko-KR" altLang="en-US"/>
+          </a:p>
+        </p:txBody>
       </p:sp>
       <p:sp>
         <p:nvSpPr>
@@ -17561,6 +18840,13 @@
             </a:outerShdw>
           </a:effectLst>
         </p:spPr>
+        <p:txBody>
+          <a:bodyPr/>
+          <a:lstStyle/>
+          <a:p>
+            <a:endParaRPr lang="ko-KR" altLang="en-US"/>
+          </a:p>
+        </p:txBody>
       </p:sp>
       <p:sp>
         <p:nvSpPr>
@@ -17580,6 +18866,13 @@
             <a:srgbClr val="C1121F"/>
           </a:solidFill>
         </p:spPr>
+        <p:txBody>
+          <a:bodyPr/>
+          <a:lstStyle/>
+          <a:p>
+            <a:endParaRPr lang="ko-KR" altLang="en-US"/>
+          </a:p>
+        </p:txBody>
       </p:sp>
       <p:sp>
         <p:nvSpPr>
@@ -17787,6 +19080,13 @@
             </a:outerShdw>
           </a:effectLst>
         </p:spPr>
+        <p:txBody>
+          <a:bodyPr/>
+          <a:lstStyle/>
+          <a:p>
+            <a:endParaRPr lang="ko-KR" altLang="en-US"/>
+          </a:p>
+        </p:txBody>
       </p:sp>
       <p:sp>
         <p:nvSpPr>
@@ -17806,6 +19106,13 @@
             <a:srgbClr val="13294B"/>
           </a:solidFill>
         </p:spPr>
+        <p:txBody>
+          <a:bodyPr/>
+          <a:lstStyle/>
+          <a:p>
+            <a:endParaRPr lang="ko-KR" altLang="en-US"/>
+          </a:p>
+        </p:txBody>
       </p:sp>
       <p:sp>
         <p:nvSpPr>
@@ -18013,6 +19320,13 @@
             </a:outerShdw>
           </a:effectLst>
         </p:spPr>
+        <p:txBody>
+          <a:bodyPr/>
+          <a:lstStyle/>
+          <a:p>
+            <a:endParaRPr lang="ko-KR" altLang="en-US"/>
+          </a:p>
+        </p:txBody>
       </p:sp>
       <p:sp>
         <p:nvSpPr>
@@ -18032,6 +19346,13 @@
             <a:srgbClr val="1B998B"/>
           </a:solidFill>
         </p:spPr>
+        <p:txBody>
+          <a:bodyPr/>
+          <a:lstStyle/>
+          <a:p>
+            <a:endParaRPr lang="ko-KR" altLang="en-US"/>
+          </a:p>
+        </p:txBody>
       </p:sp>
       <p:sp>
         <p:nvSpPr>
@@ -18288,6 +19609,13 @@
             </a:outerShdw>
           </a:effectLst>
         </p:spPr>
+        <p:txBody>
+          <a:bodyPr/>
+          <a:lstStyle/>
+          <a:p>
+            <a:endParaRPr lang="ko-KR" altLang="en-US"/>
+          </a:p>
+        </p:txBody>
       </p:sp>
       <p:sp>
         <p:nvSpPr>
@@ -18576,9 +19904,27 @@
             <a:tbl>
               <a:tblPr/>
               <a:tblGrid>
-                <a:gridCol w="2286000"/>
-                <a:gridCol w="3291840"/>
-                <a:gridCol w="1188720"/>
+                <a:gridCol w="2286000">
+                  <a:extLst>
+                    <a:ext uri="{9D8B030D-6E8A-4147-A177-3AD203B41FA5}">
+                      <a16:colId xmlns:a16="http://schemas.microsoft.com/office/drawing/2014/main" val="20000"/>
+                    </a:ext>
+                  </a:extLst>
+                </a:gridCol>
+                <a:gridCol w="3291840">
+                  <a:extLst>
+                    <a:ext uri="{9D8B030D-6E8A-4147-A177-3AD203B41FA5}">
+                      <a16:colId xmlns:a16="http://schemas.microsoft.com/office/drawing/2014/main" val="20001"/>
+                    </a:ext>
+                  </a:extLst>
+                </a:gridCol>
+                <a:gridCol w="1188720">
+                  <a:extLst>
+                    <a:ext uri="{9D8B030D-6E8A-4147-A177-3AD203B41FA5}">
+                      <a16:colId xmlns:a16="http://schemas.microsoft.com/office/drawing/2014/main" val="20002"/>
+                    </a:ext>
+                  </a:extLst>
+                </a:gridCol>
               </a:tblGrid>
               <a:tr h="384048">
                 <a:tc>
@@ -18785,6 +20131,11 @@
                     </a:solidFill>
                   </a:tcPr>
                 </a:tc>
+                <a:extLst>
+                  <a:ext uri="{0D108BD9-81ED-4DB2-BD59-A6C34878D82A}">
+                    <a16:rowId xmlns:a16="http://schemas.microsoft.com/office/drawing/2014/main" val="10000"/>
+                  </a:ext>
+                </a:extLst>
               </a:tr>
               <a:tr h="384048">
                 <a:tc>
@@ -18991,6 +20342,11 @@
                     </a:solidFill>
                   </a:tcPr>
                 </a:tc>
+                <a:extLst>
+                  <a:ext uri="{0D108BD9-81ED-4DB2-BD59-A6C34878D82A}">
+                    <a16:rowId xmlns:a16="http://schemas.microsoft.com/office/drawing/2014/main" val="10001"/>
+                  </a:ext>
+                </a:extLst>
               </a:tr>
               <a:tr h="384048">
                 <a:tc>
@@ -19197,6 +20553,11 @@
                     </a:solidFill>
                   </a:tcPr>
                 </a:tc>
+                <a:extLst>
+                  <a:ext uri="{0D108BD9-81ED-4DB2-BD59-A6C34878D82A}">
+                    <a16:rowId xmlns:a16="http://schemas.microsoft.com/office/drawing/2014/main" val="10002"/>
+                  </a:ext>
+                </a:extLst>
               </a:tr>
               <a:tr h="384048">
                 <a:tc>
@@ -19403,6 +20764,11 @@
                     </a:solidFill>
                   </a:tcPr>
                 </a:tc>
+                <a:extLst>
+                  <a:ext uri="{0D108BD9-81ED-4DB2-BD59-A6C34878D82A}">
+                    <a16:rowId xmlns:a16="http://schemas.microsoft.com/office/drawing/2014/main" val="10003"/>
+                  </a:ext>
+                </a:extLst>
               </a:tr>
               <a:tr h="384048">
                 <a:tc>
@@ -19609,6 +20975,11 @@
                     </a:solidFill>
                   </a:tcPr>
                 </a:tc>
+                <a:extLst>
+                  <a:ext uri="{0D108BD9-81ED-4DB2-BD59-A6C34878D82A}">
+                    <a16:rowId xmlns:a16="http://schemas.microsoft.com/office/drawing/2014/main" val="10004"/>
+                  </a:ext>
+                </a:extLst>
               </a:tr>
               <a:tr h="384048">
                 <a:tc>
@@ -19815,6 +21186,11 @@
                     </a:solidFill>
                   </a:tcPr>
                 </a:tc>
+                <a:extLst>
+                  <a:ext uri="{0D108BD9-81ED-4DB2-BD59-A6C34878D82A}">
+                    <a16:rowId xmlns:a16="http://schemas.microsoft.com/office/drawing/2014/main" val="10005"/>
+                  </a:ext>
+                </a:extLst>
               </a:tr>
               <a:tr h="384048">
                 <a:tc>
@@ -20021,6 +21397,11 @@
                     </a:solidFill>
                   </a:tcPr>
                 </a:tc>
+                <a:extLst>
+                  <a:ext uri="{0D108BD9-81ED-4DB2-BD59-A6C34878D82A}">
+                    <a16:rowId xmlns:a16="http://schemas.microsoft.com/office/drawing/2014/main" val="10006"/>
+                  </a:ext>
+                </a:extLst>
               </a:tr>
               <a:tr h="384048">
                 <a:tc>
@@ -20227,6 +21608,11 @@
                     </a:solidFill>
                   </a:tcPr>
                 </a:tc>
+                <a:extLst>
+                  <a:ext uri="{0D108BD9-81ED-4DB2-BD59-A6C34878D82A}">
+                    <a16:rowId xmlns:a16="http://schemas.microsoft.com/office/drawing/2014/main" val="10007"/>
+                  </a:ext>
+                </a:extLst>
               </a:tr>
             </a:tbl>
           </a:graphicData>
@@ -20295,6 +21681,13 @@
             </a:outerShdw>
           </a:effectLst>
         </p:spPr>
+        <p:txBody>
+          <a:bodyPr/>
+          <a:lstStyle/>
+          <a:p>
+            <a:endParaRPr lang="ko-KR" altLang="en-US"/>
+          </a:p>
+        </p:txBody>
       </p:sp>
       <p:sp>
         <p:nvSpPr>
@@ -20314,6 +21707,13 @@
             <a:srgbClr val="C1121F"/>
           </a:solidFill>
         </p:spPr>
+        <p:txBody>
+          <a:bodyPr/>
+          <a:lstStyle/>
+          <a:p>
+            <a:endParaRPr lang="ko-KR" altLang="en-US"/>
+          </a:p>
+        </p:txBody>
       </p:sp>
       <p:sp>
         <p:nvSpPr>
@@ -20417,7 +21817,7 @@
         </p:xfrm>
         <a:graphic>
           <a:graphicData uri="http://schemas.openxmlformats.org/drawingml/2006/chart">
-            <c:chart xmlns:c="http://schemas.openxmlformats.org/drawingml/2006/chart" xmlns:r="http://schemas.openxmlformats.org/officeDocument/2006/relationships" r:id="rId1"/>
+            <c:chart xmlns:c="http://schemas.openxmlformats.org/drawingml/2006/chart" xmlns:r="http://schemas.openxmlformats.org/officeDocument/2006/relationships" r:id="rId3"/>
           </a:graphicData>
         </a:graphic>
       </p:graphicFrame>
@@ -20661,6 +22061,13 @@
             </a:outerShdw>
           </a:effectLst>
         </p:spPr>
+        <p:txBody>
+          <a:bodyPr/>
+          <a:lstStyle/>
+          <a:p>
+            <a:endParaRPr lang="ko-KR" altLang="en-US"/>
+          </a:p>
+        </p:txBody>
       </p:sp>
       <p:sp>
         <p:nvSpPr>
@@ -20680,6 +22087,13 @@
             <a:srgbClr val="1B998B"/>
           </a:solidFill>
         </p:spPr>
+        <p:txBody>
+          <a:bodyPr/>
+          <a:lstStyle/>
+          <a:p>
+            <a:endParaRPr lang="ko-KR" altLang="en-US"/>
+          </a:p>
+        </p:txBody>
       </p:sp>
       <p:sp>
         <p:nvSpPr>
@@ -20767,14 +22181,6 @@
               </a:rPr>
               <a:t>— corrected convenience-yield spread (DGS3MO − overnight SOFR).   </a:t>
             </a:r>
-            <a:endParaRPr lang="en-US" sz="1200" dirty="0">
-              <a:solidFill>
-                <a:srgbClr val="33425C"/>
-              </a:solidFill>
-              <a:latin typeface="Calibri" pitchFamily="34" charset="0"/>
-              <a:ea typeface="Calibri" pitchFamily="34" charset="-122"/>
-              <a:cs typeface="Calibri" pitchFamily="34" charset="-120"/>
-            </a:endParaRPr>
           </a:p>
           <a:p>
             <a:pPr marL="0" indent="0">
@@ -20805,14 +22211,6 @@
               </a:rPr>
               <a:t>— USDT+USDC supply, now ~$260B.   </a:t>
             </a:r>
-            <a:endParaRPr lang="en-US" sz="1200" dirty="0">
-              <a:solidFill>
-                <a:srgbClr val="33425C"/>
-              </a:solidFill>
-              <a:latin typeface="Calibri" pitchFamily="34" charset="0"/>
-              <a:ea typeface="Calibri" pitchFamily="34" charset="-122"/>
-              <a:cs typeface="Calibri" pitchFamily="34" charset="-120"/>
-            </a:endParaRPr>
           </a:p>
           <a:p>
             <a:pPr marL="0" indent="0">
@@ -20872,6 +22270,13 @@
             </a:outerShdw>
           </a:effectLst>
         </p:spPr>
+        <p:txBody>
+          <a:bodyPr/>
+          <a:lstStyle/>
+          <a:p>
+            <a:endParaRPr lang="ko-KR" altLang="en-US"/>
+          </a:p>
+        </p:txBody>
       </p:sp>
       <p:sp>
         <p:nvSpPr>
@@ -20891,6 +22296,13 @@
             <a:srgbClr val="E8A12C"/>
           </a:solidFill>
         </p:spPr>
+        <p:txBody>
+          <a:bodyPr/>
+          <a:lstStyle/>
+          <a:p>
+            <a:endParaRPr lang="ko-KR" altLang="en-US"/>
+          </a:p>
+        </p:txBody>
       </p:sp>
       <p:sp>
         <p:nvSpPr>
@@ -21056,7 +22468,7 @@
           <p:nvPr/>
         </p:nvPicPr>
         <p:blipFill>
-          <a:blip r:embed="rId1"/>
+          <a:blip r:embed="rId3"/>
           <a:stretch>
             <a:fillRect/>
           </a:stretch>
@@ -21330,6 +22742,8 @@
       </a:bgFillStyleLst>
     </a:fmtScheme>
   </a:themeElements>
+  <a:objectDefaults/>
+  <a:extraClrSchemeLst/>
   <a:extLst>
     <a:ext uri="{05A4C25C-085E-4340-85A3-A5531E510DB2}">
       <thm15:themeFamily xmlns:thm15="http://schemas.microsoft.com/office/thememl/2012/main" name="Office Theme" id="{62F939B6-93AF-4DB8-9C6B-D6C7DFDC589F}" vid="{4A3C46E8-61CC-4603-A589-7422A47A8E4A}"/>
@@ -21589,6 +23003,8 @@
       </a:bgFillStyleLst>
     </a:fmtScheme>
   </a:themeElements>
+  <a:objectDefaults/>
+  <a:extraClrSchemeLst/>
   <a:extLst>
     <a:ext uri="{05A4C25C-085E-4340-85A3-A5531E510DB2}">
       <thm15:themeFamily xmlns:thm15="http://schemas.microsoft.com/office/thememl/2012/main" name="Office Theme" id="{62F939B6-93AF-4DB8-9C6B-D6C7DFDC589F}" vid="{4A3C46E8-61CC-4603-A589-7422A47A8E4A}"/>

</xml_diff>